<commit_message>
feat(slides): ba bảng màu chọn bằng --theme, mặc định nền xám than
Bài thuyết trình trước đây khóa cứng một bảng màu nền xanh đen #0B1220,
chủ repo thấy tối quá khi trình chiếu.

- build_slides_pptx.py: THEMES gom ba bảng màu slate (#1E293B, mặc định),
  dark (#0B1220, bản cũ) và light (#FAFAF9, bản trước patch dark); cờ
  --theme và --out; THEME_IMAGES chọn bộ ảnh có nền khớp từng theme.
- build_dark_assets.py: cờ --theme dark|slate cho nền ma trận nhầm lẫn,
  cờ --skip-svg để chỉ vẽ lại ảnh mà không ghi đè hai SVG đã commit.
  Khối argparse đặt trước vòng lặp ghi SVG vì vòng lặp chạy ở cấp module.
- confusion_slate.png: ma trận nhầm lẫn nền #1E293B, thang màu chỉnh theo
  nền mới; confusion_dark.png giữ nguyên cho theme dark.
- CS221_slide.pptx dựng lại theme slate: 18 slide, đủ ghi chú người nói.

Nội dung slide không đổi, chỉ đổi màu. 146 kiểm thử vẫn qua.
</commit_message>
<xml_diff>
--- a/report/CS221_slide.pptx
+++ b/report/CS221_slide.pptx
@@ -4711,7 +4711,7 @@
     <p:bg>
       <p:bgPr>
         <a:solidFill>
-          <a:srgbClr val="0B1220"/>
+          <a:srgbClr val="1E293B"/>
         </a:solidFill>
         <a:effectLst/>
       </p:bgPr>
@@ -4738,7 +4738,7 @@
             <a:avLst/>
           </a:prstGeom>
           <a:solidFill>
-            <a:srgbClr val="164E4A"/>
+            <a:srgbClr val="155E59"/>
           </a:solidFill>
           <a:ln>
             <a:noFill/>
@@ -4797,7 +4797,7 @@
             <a:r>
               <a:rPr sz="4000" b="1" i="0">
                 <a:solidFill>
-                  <a:srgbClr val="F2F6FB"/>
+                  <a:srgbClr val="F8FAFC"/>
                 </a:solidFill>
                 <a:latin typeface="Calibri Light"/>
               </a:rPr>
@@ -4915,7 +4915,7 @@
             <a:r>
               <a:rPr sz="1150" b="0" i="0">
                 <a:solidFill>
-                  <a:srgbClr val="93A6C0"/>
+                  <a:srgbClr val="94A3B8"/>
                 </a:solidFill>
                 <a:latin typeface="Calibri"/>
               </a:rPr>
@@ -4931,7 +4931,7 @@
             <a:r>
               <a:rPr sz="1150" b="0" i="0">
                 <a:solidFill>
-                  <a:srgbClr val="93A6C0"/>
+                  <a:srgbClr val="94A3B8"/>
                 </a:solidFill>
                 <a:latin typeface="Calibri"/>
               </a:rPr>
@@ -4947,7 +4947,7 @@
             <a:r>
               <a:rPr sz="1150" b="0" i="0">
                 <a:solidFill>
-                  <a:srgbClr val="93A6C0"/>
+                  <a:srgbClr val="94A3B8"/>
                 </a:solidFill>
                 <a:latin typeface="Calibri"/>
               </a:rPr>
@@ -4963,7 +4963,7 @@
             <a:r>
               <a:rPr sz="1150" b="0" i="0">
                 <a:solidFill>
-                  <a:srgbClr val="93A6C0"/>
+                  <a:srgbClr val="94A3B8"/>
                 </a:solidFill>
                 <a:latin typeface="Calibri"/>
               </a:rPr>
@@ -5002,7 +5002,7 @@
             <a:r>
               <a:rPr sz="1150" b="0" i="0">
                 <a:solidFill>
-                  <a:srgbClr val="93A6C0"/>
+                  <a:srgbClr val="94A3B8"/>
                 </a:solidFill>
                 <a:latin typeface="Calibri"/>
               </a:rPr>
@@ -5018,7 +5018,7 @@
             <a:r>
               <a:rPr sz="1150" b="0" i="0">
                 <a:solidFill>
-                  <a:srgbClr val="93A6C0"/>
+                  <a:srgbClr val="94A3B8"/>
                 </a:solidFill>
                 <a:latin typeface="Calibri"/>
               </a:rPr>
@@ -5034,7 +5034,7 @@
             <a:r>
               <a:rPr sz="1150" b="0" i="0">
                 <a:solidFill>
-                  <a:srgbClr val="93A6C0"/>
+                  <a:srgbClr val="94A3B8"/>
                 </a:solidFill>
                 <a:latin typeface="Calibri"/>
               </a:rPr>
@@ -5057,7 +5057,7 @@
     <p:bg>
       <p:bgPr>
         <a:solidFill>
-          <a:srgbClr val="0B1220"/>
+          <a:srgbClr val="1E293B"/>
         </a:solidFill>
         <a:effectLst/>
       </p:bgPr>
@@ -5133,7 +5133,7 @@
             <a:r>
               <a:rPr sz="2900" b="1" i="0">
                 <a:solidFill>
-                  <a:srgbClr val="F2F6FB"/>
+                  <a:srgbClr val="F8FAFC"/>
                 </a:solidFill>
                 <a:latin typeface="Calibri Light"/>
               </a:rPr>
@@ -5212,7 +5212,7 @@
             <a:r>
               <a:rPr sz="1100" b="0" i="0">
                 <a:solidFill>
-                  <a:srgbClr val="55688A"/>
+                  <a:srgbClr val="8296B0"/>
                 </a:solidFill>
                 <a:latin typeface="Calibri"/>
               </a:rPr>
@@ -5265,7 +5265,7 @@
                   </a:txBody>
                   <a:tcPr anchor="ctr" marL="100584" marR="100584" marT="36576" marB="36576">
                     <a:solidFill>
-                      <a:srgbClr val="12303A"/>
+                      <a:srgbClr val="334155"/>
                     </a:solidFill>
                   </a:tcPr>
                 </a:tc>
@@ -5288,7 +5288,7 @@
                   </a:txBody>
                   <a:tcPr anchor="ctr" marL="100584" marR="100584" marT="36576" marB="36576">
                     <a:solidFill>
-                      <a:srgbClr val="12303A"/>
+                      <a:srgbClr val="334155"/>
                     </a:solidFill>
                   </a:tcPr>
                 </a:tc>
@@ -5311,7 +5311,7 @@
                   </a:txBody>
                   <a:tcPr anchor="ctr" marL="100584" marR="100584" marT="36576" marB="36576">
                     <a:solidFill>
-                      <a:srgbClr val="12303A"/>
+                      <a:srgbClr val="334155"/>
                     </a:solidFill>
                   </a:tcPr>
                 </a:tc>
@@ -5334,7 +5334,7 @@
                   </a:txBody>
                   <a:tcPr anchor="ctr" marL="100584" marR="100584" marT="36576" marB="36576">
                     <a:solidFill>
-                      <a:srgbClr val="12303A"/>
+                      <a:srgbClr val="334155"/>
                     </a:solidFill>
                   </a:tcPr>
                 </a:tc>
@@ -5349,7 +5349,7 @@
                       <a:r>
                         <a:rPr sz="1450" b="0" i="0">
                           <a:solidFill>
-                            <a:srgbClr val="C5D2E4"/>
+                            <a:srgbClr val="CBD5E1"/>
                           </a:solidFill>
                           <a:latin typeface="Calibri"/>
                         </a:rPr>
@@ -5359,7 +5359,7 @@
                   </a:txBody>
                   <a:tcPr anchor="ctr" marL="100584" marR="100584" marT="36576" marB="36576">
                     <a:solidFill>
-                      <a:srgbClr val="0E1929"/>
+                      <a:srgbClr val="243247"/>
                     </a:solidFill>
                   </a:tcPr>
                 </a:tc>
@@ -5372,7 +5372,7 @@
                       <a:r>
                         <a:rPr sz="1450" b="0" i="0">
                           <a:solidFill>
-                            <a:srgbClr val="C5D2E4"/>
+                            <a:srgbClr val="CBD5E1"/>
                           </a:solidFill>
                           <a:latin typeface="Calibri"/>
                         </a:rPr>
@@ -5382,7 +5382,7 @@
                   </a:txBody>
                   <a:tcPr anchor="ctr" marL="100584" marR="100584" marT="36576" marB="36576">
                     <a:solidFill>
-                      <a:srgbClr val="0E1929"/>
+                      <a:srgbClr val="243247"/>
                     </a:solidFill>
                   </a:tcPr>
                 </a:tc>
@@ -5395,7 +5395,7 @@
                       <a:r>
                         <a:rPr sz="1450" b="0" i="0">
                           <a:solidFill>
-                            <a:srgbClr val="C5D2E4"/>
+                            <a:srgbClr val="CBD5E1"/>
                           </a:solidFill>
                           <a:latin typeface="Calibri"/>
                         </a:rPr>
@@ -5405,7 +5405,7 @@
                   </a:txBody>
                   <a:tcPr anchor="ctr" marL="100584" marR="100584" marT="36576" marB="36576">
                     <a:solidFill>
-                      <a:srgbClr val="0E1929"/>
+                      <a:srgbClr val="243247"/>
                     </a:solidFill>
                   </a:tcPr>
                 </a:tc>
@@ -5418,7 +5418,7 @@
                       <a:r>
                         <a:rPr sz="1450" b="0" i="0">
                           <a:solidFill>
-                            <a:srgbClr val="C5D2E4"/>
+                            <a:srgbClr val="CBD5E1"/>
                           </a:solidFill>
                           <a:latin typeface="Calibri"/>
                         </a:rPr>
@@ -5428,7 +5428,7 @@
                   </a:txBody>
                   <a:tcPr anchor="ctr" marL="100584" marR="100584" marT="36576" marB="36576">
                     <a:solidFill>
-                      <a:srgbClr val="0E1929"/>
+                      <a:srgbClr val="243247"/>
                     </a:solidFill>
                   </a:tcPr>
                 </a:tc>
@@ -5443,7 +5443,7 @@
                       <a:r>
                         <a:rPr sz="1450" b="1" i="0">
                           <a:solidFill>
-                            <a:srgbClr val="F2F6FB"/>
+                            <a:srgbClr val="F8FAFC"/>
                           </a:solidFill>
                           <a:latin typeface="Calibri"/>
                         </a:rPr>
@@ -5453,7 +5453,7 @@
                   </a:txBody>
                   <a:tcPr anchor="ctr" marL="100584" marR="100584" marT="36576" marB="36576">
                     <a:solidFill>
-                      <a:srgbClr val="12303A"/>
+                      <a:srgbClr val="334155"/>
                     </a:solidFill>
                   </a:tcPr>
                 </a:tc>
@@ -5466,7 +5466,7 @@
                       <a:r>
                         <a:rPr sz="1450" b="1" i="0">
                           <a:solidFill>
-                            <a:srgbClr val="F2F6FB"/>
+                            <a:srgbClr val="F8FAFC"/>
                           </a:solidFill>
                           <a:latin typeface="Calibri"/>
                         </a:rPr>
@@ -5476,7 +5476,7 @@
                   </a:txBody>
                   <a:tcPr anchor="ctr" marL="100584" marR="100584" marT="36576" marB="36576">
                     <a:solidFill>
-                      <a:srgbClr val="12303A"/>
+                      <a:srgbClr val="334155"/>
                     </a:solidFill>
                   </a:tcPr>
                 </a:tc>
@@ -5489,7 +5489,7 @@
                       <a:r>
                         <a:rPr sz="1450" b="1" i="0">
                           <a:solidFill>
-                            <a:srgbClr val="F2F6FB"/>
+                            <a:srgbClr val="F8FAFC"/>
                           </a:solidFill>
                           <a:latin typeface="Calibri"/>
                         </a:rPr>
@@ -5499,7 +5499,7 @@
                   </a:txBody>
                   <a:tcPr anchor="ctr" marL="100584" marR="100584" marT="36576" marB="36576">
                     <a:solidFill>
-                      <a:srgbClr val="12303A"/>
+                      <a:srgbClr val="334155"/>
                     </a:solidFill>
                   </a:tcPr>
                 </a:tc>
@@ -5512,7 +5512,7 @@
                       <a:r>
                         <a:rPr sz="1450" b="1" i="0">
                           <a:solidFill>
-                            <a:srgbClr val="F2F6FB"/>
+                            <a:srgbClr val="F8FAFC"/>
                           </a:solidFill>
                           <a:latin typeface="Calibri"/>
                         </a:rPr>
@@ -5522,7 +5522,7 @@
                   </a:txBody>
                   <a:tcPr anchor="ctr" marL="100584" marR="100584" marT="36576" marB="36576">
                     <a:solidFill>
-                      <a:srgbClr val="12303A"/>
+                      <a:srgbClr val="334155"/>
                     </a:solidFill>
                   </a:tcPr>
                 </a:tc>
@@ -5537,7 +5537,7 @@
                       <a:r>
                         <a:rPr sz="1450" b="0" i="0">
                           <a:solidFill>
-                            <a:srgbClr val="C5D2E4"/>
+                            <a:srgbClr val="CBD5E1"/>
                           </a:solidFill>
                           <a:latin typeface="Calibri"/>
                         </a:rPr>
@@ -5547,7 +5547,7 @@
                   </a:txBody>
                   <a:tcPr anchor="ctr" marL="100584" marR="100584" marT="36576" marB="36576">
                     <a:solidFill>
-                      <a:srgbClr val="0E1929"/>
+                      <a:srgbClr val="243247"/>
                     </a:solidFill>
                   </a:tcPr>
                 </a:tc>
@@ -5560,7 +5560,7 @@
                       <a:r>
                         <a:rPr sz="1450" b="0" i="0">
                           <a:solidFill>
-                            <a:srgbClr val="C5D2E4"/>
+                            <a:srgbClr val="CBD5E1"/>
                           </a:solidFill>
                           <a:latin typeface="Calibri"/>
                         </a:rPr>
@@ -5570,7 +5570,7 @@
                   </a:txBody>
                   <a:tcPr anchor="ctr" marL="100584" marR="100584" marT="36576" marB="36576">
                     <a:solidFill>
-                      <a:srgbClr val="0E1929"/>
+                      <a:srgbClr val="243247"/>
                     </a:solidFill>
                   </a:tcPr>
                 </a:tc>
@@ -5583,7 +5583,7 @@
                       <a:r>
                         <a:rPr sz="1450" b="0" i="0">
                           <a:solidFill>
-                            <a:srgbClr val="C5D2E4"/>
+                            <a:srgbClr val="CBD5E1"/>
                           </a:solidFill>
                           <a:latin typeface="Calibri"/>
                         </a:rPr>
@@ -5593,7 +5593,7 @@
                   </a:txBody>
                   <a:tcPr anchor="ctr" marL="100584" marR="100584" marT="36576" marB="36576">
                     <a:solidFill>
-                      <a:srgbClr val="0E1929"/>
+                      <a:srgbClr val="243247"/>
                     </a:solidFill>
                   </a:tcPr>
                 </a:tc>
@@ -5606,7 +5606,7 @@
                       <a:r>
                         <a:rPr sz="1450" b="0" i="0">
                           <a:solidFill>
-                            <a:srgbClr val="C5D2E4"/>
+                            <a:srgbClr val="CBD5E1"/>
                           </a:solidFill>
                           <a:latin typeface="Calibri"/>
                         </a:rPr>
@@ -5616,7 +5616,7 @@
                   </a:txBody>
                   <a:tcPr anchor="ctr" marL="100584" marR="100584" marT="36576" marB="36576">
                     <a:solidFill>
-                      <a:srgbClr val="0E1929"/>
+                      <a:srgbClr val="243247"/>
                     </a:solidFill>
                   </a:tcPr>
                 </a:tc>
@@ -5627,7 +5627,7 @@
       </p:graphicFrame>
       <p:pic>
         <p:nvPicPr>
-          <p:cNvPr id="7" name="Picture 6" descr="confusion_dark.png"/>
+          <p:cNvPr id="7" name="Picture 6" descr="confusion_slate.png"/>
           <p:cNvPicPr>
             <a:picLocks noChangeAspect="1"/>
           </p:cNvPicPr>
@@ -5687,7 +5687,7 @@
             <a:r>
               <a:rPr sz="1500" b="0" i="0">
                 <a:solidFill>
-                  <a:srgbClr val="C5D2E4"/>
+                  <a:srgbClr val="CBD5E1"/>
                 </a:solidFill>
                 <a:latin typeface="Calibri"/>
               </a:rPr>
@@ -5711,7 +5711,7 @@
             <a:r>
               <a:rPr sz="1500" b="0" i="0">
                 <a:solidFill>
-                  <a:srgbClr val="C5D2E4"/>
+                  <a:srgbClr val="CBD5E1"/>
                 </a:solidFill>
                 <a:latin typeface="Calibri"/>
               </a:rPr>
@@ -5735,7 +5735,7 @@
             <a:r>
               <a:rPr sz="1500" b="0" i="0">
                 <a:solidFill>
-                  <a:srgbClr val="C5D2E4"/>
+                  <a:srgbClr val="CBD5E1"/>
                 </a:solidFill>
                 <a:latin typeface="Calibri"/>
               </a:rPr>
@@ -5758,7 +5758,7 @@
     <p:bg>
       <p:bgPr>
         <a:solidFill>
-          <a:srgbClr val="0B1220"/>
+          <a:srgbClr val="1E293B"/>
         </a:solidFill>
         <a:effectLst/>
       </p:bgPr>
@@ -5834,7 +5834,7 @@
             <a:r>
               <a:rPr sz="2900" b="1" i="0">
                 <a:solidFill>
-                  <a:srgbClr val="F2F6FB"/>
+                  <a:srgbClr val="F8FAFC"/>
                 </a:solidFill>
                 <a:latin typeface="Calibri Light"/>
               </a:rPr>
@@ -5913,7 +5913,7 @@
             <a:r>
               <a:rPr sz="1100" b="0" i="0">
                 <a:solidFill>
-                  <a:srgbClr val="55688A"/>
+                  <a:srgbClr val="8296B0"/>
                 </a:solidFill>
                 <a:latin typeface="Calibri"/>
               </a:rPr>
@@ -5968,7 +5968,7 @@
                   </a:txBody>
                   <a:tcPr anchor="ctr" marL="100584" marR="100584" marT="36576" marB="36576">
                     <a:solidFill>
-                      <a:srgbClr val="12303A"/>
+                      <a:srgbClr val="334155"/>
                     </a:solidFill>
                   </a:tcPr>
                 </a:tc>
@@ -5991,7 +5991,7 @@
                   </a:txBody>
                   <a:tcPr anchor="ctr" marL="100584" marR="100584" marT="36576" marB="36576">
                     <a:solidFill>
-                      <a:srgbClr val="12303A"/>
+                      <a:srgbClr val="334155"/>
                     </a:solidFill>
                   </a:tcPr>
                 </a:tc>
@@ -6014,7 +6014,7 @@
                   </a:txBody>
                   <a:tcPr anchor="ctr" marL="100584" marR="100584" marT="36576" marB="36576">
                     <a:solidFill>
-                      <a:srgbClr val="12303A"/>
+                      <a:srgbClr val="334155"/>
                     </a:solidFill>
                   </a:tcPr>
                 </a:tc>
@@ -6037,7 +6037,7 @@
                   </a:txBody>
                   <a:tcPr anchor="ctr" marL="100584" marR="100584" marT="36576" marB="36576">
                     <a:solidFill>
-                      <a:srgbClr val="12303A"/>
+                      <a:srgbClr val="334155"/>
                     </a:solidFill>
                   </a:tcPr>
                 </a:tc>
@@ -6060,7 +6060,7 @@
                   </a:txBody>
                   <a:tcPr anchor="ctr" marL="100584" marR="100584" marT="36576" marB="36576">
                     <a:solidFill>
-                      <a:srgbClr val="12303A"/>
+                      <a:srgbClr val="334155"/>
                     </a:solidFill>
                   </a:tcPr>
                 </a:tc>
@@ -6083,7 +6083,7 @@
                   </a:txBody>
                   <a:tcPr anchor="ctr" marL="100584" marR="100584" marT="36576" marB="36576">
                     <a:solidFill>
-                      <a:srgbClr val="12303A"/>
+                      <a:srgbClr val="334155"/>
                     </a:solidFill>
                   </a:tcPr>
                 </a:tc>
@@ -6098,7 +6098,7 @@
                       <a:r>
                         <a:rPr sz="1300" b="0" i="0">
                           <a:solidFill>
-                            <a:srgbClr val="C5D2E4"/>
+                            <a:srgbClr val="CBD5E1"/>
                           </a:solidFill>
                           <a:latin typeface="Calibri"/>
                         </a:rPr>
@@ -6108,7 +6108,7 @@
                   </a:txBody>
                   <a:tcPr anchor="ctr" marL="100584" marR="100584" marT="36576" marB="36576">
                     <a:solidFill>
-                      <a:srgbClr val="0E1929"/>
+                      <a:srgbClr val="243247"/>
                     </a:solidFill>
                   </a:tcPr>
                 </a:tc>
@@ -6121,7 +6121,7 @@
                       <a:r>
                         <a:rPr sz="1300" b="0" i="0">
                           <a:solidFill>
-                            <a:srgbClr val="C5D2E4"/>
+                            <a:srgbClr val="CBD5E1"/>
                           </a:solidFill>
                           <a:latin typeface="Calibri"/>
                         </a:rPr>
@@ -6131,7 +6131,7 @@
                   </a:txBody>
                   <a:tcPr anchor="ctr" marL="100584" marR="100584" marT="36576" marB="36576">
                     <a:solidFill>
-                      <a:srgbClr val="0E1929"/>
+                      <a:srgbClr val="243247"/>
                     </a:solidFill>
                   </a:tcPr>
                 </a:tc>
@@ -6144,7 +6144,7 @@
                       <a:r>
                         <a:rPr sz="1300" b="0" i="0">
                           <a:solidFill>
-                            <a:srgbClr val="C5D2E4"/>
+                            <a:srgbClr val="CBD5E1"/>
                           </a:solidFill>
                           <a:latin typeface="Calibri"/>
                         </a:rPr>
@@ -6154,7 +6154,7 @@
                   </a:txBody>
                   <a:tcPr anchor="ctr" marL="100584" marR="100584" marT="36576" marB="36576">
                     <a:solidFill>
-                      <a:srgbClr val="0E1929"/>
+                      <a:srgbClr val="243247"/>
                     </a:solidFill>
                   </a:tcPr>
                 </a:tc>
@@ -6167,7 +6167,7 @@
                       <a:r>
                         <a:rPr sz="1300" b="0" i="0">
                           <a:solidFill>
-                            <a:srgbClr val="C5D2E4"/>
+                            <a:srgbClr val="CBD5E1"/>
                           </a:solidFill>
                           <a:latin typeface="Calibri"/>
                         </a:rPr>
@@ -6177,7 +6177,7 @@
                   </a:txBody>
                   <a:tcPr anchor="ctr" marL="100584" marR="100584" marT="36576" marB="36576">
                     <a:solidFill>
-                      <a:srgbClr val="0E1929"/>
+                      <a:srgbClr val="243247"/>
                     </a:solidFill>
                   </a:tcPr>
                 </a:tc>
@@ -6190,7 +6190,7 @@
                       <a:r>
                         <a:rPr sz="1300" b="0" i="0">
                           <a:solidFill>
-                            <a:srgbClr val="C5D2E4"/>
+                            <a:srgbClr val="CBD5E1"/>
                           </a:solidFill>
                           <a:latin typeface="Calibri"/>
                         </a:rPr>
@@ -6200,7 +6200,7 @@
                   </a:txBody>
                   <a:tcPr anchor="ctr" marL="100584" marR="100584" marT="36576" marB="36576">
                     <a:solidFill>
-                      <a:srgbClr val="0E1929"/>
+                      <a:srgbClr val="243247"/>
                     </a:solidFill>
                   </a:tcPr>
                 </a:tc>
@@ -6213,7 +6213,7 @@
                       <a:r>
                         <a:rPr sz="1300" b="0" i="0">
                           <a:solidFill>
-                            <a:srgbClr val="C5D2E4"/>
+                            <a:srgbClr val="CBD5E1"/>
                           </a:solidFill>
                           <a:latin typeface="Calibri"/>
                         </a:rPr>
@@ -6223,7 +6223,7 @@
                   </a:txBody>
                   <a:tcPr anchor="ctr" marL="100584" marR="100584" marT="36576" marB="36576">
                     <a:solidFill>
-                      <a:srgbClr val="0E1929"/>
+                      <a:srgbClr val="243247"/>
                     </a:solidFill>
                   </a:tcPr>
                 </a:tc>
@@ -6238,7 +6238,7 @@
                       <a:r>
                         <a:rPr sz="1300" b="0" i="0">
                           <a:solidFill>
-                            <a:srgbClr val="C5D2E4"/>
+                            <a:srgbClr val="CBD5E1"/>
                           </a:solidFill>
                           <a:latin typeface="Calibri"/>
                         </a:rPr>
@@ -6248,7 +6248,7 @@
                   </a:txBody>
                   <a:tcPr anchor="ctr" marL="100584" marR="100584" marT="36576" marB="36576">
                     <a:solidFill>
-                      <a:srgbClr val="121E30"/>
+                      <a:srgbClr val="2B3A50"/>
                     </a:solidFill>
                   </a:tcPr>
                 </a:tc>
@@ -6261,7 +6261,7 @@
                       <a:r>
                         <a:rPr sz="1300" b="0" i="0">
                           <a:solidFill>
-                            <a:srgbClr val="C5D2E4"/>
+                            <a:srgbClr val="CBD5E1"/>
                           </a:solidFill>
                           <a:latin typeface="Calibri"/>
                         </a:rPr>
@@ -6271,7 +6271,7 @@
                   </a:txBody>
                   <a:tcPr anchor="ctr" marL="100584" marR="100584" marT="36576" marB="36576">
                     <a:solidFill>
-                      <a:srgbClr val="121E30"/>
+                      <a:srgbClr val="2B3A50"/>
                     </a:solidFill>
                   </a:tcPr>
                 </a:tc>
@@ -6284,7 +6284,7 @@
                       <a:r>
                         <a:rPr sz="1300" b="0" i="0">
                           <a:solidFill>
-                            <a:srgbClr val="C5D2E4"/>
+                            <a:srgbClr val="CBD5E1"/>
                           </a:solidFill>
                           <a:latin typeface="Calibri"/>
                         </a:rPr>
@@ -6294,7 +6294,7 @@
                   </a:txBody>
                   <a:tcPr anchor="ctr" marL="100584" marR="100584" marT="36576" marB="36576">
                     <a:solidFill>
-                      <a:srgbClr val="121E30"/>
+                      <a:srgbClr val="2B3A50"/>
                     </a:solidFill>
                   </a:tcPr>
                 </a:tc>
@@ -6307,7 +6307,7 @@
                       <a:r>
                         <a:rPr sz="1300" b="0" i="0">
                           <a:solidFill>
-                            <a:srgbClr val="C5D2E4"/>
+                            <a:srgbClr val="CBD5E1"/>
                           </a:solidFill>
                           <a:latin typeface="Calibri"/>
                         </a:rPr>
@@ -6317,7 +6317,7 @@
                   </a:txBody>
                   <a:tcPr anchor="ctr" marL="100584" marR="100584" marT="36576" marB="36576">
                     <a:solidFill>
-                      <a:srgbClr val="121E30"/>
+                      <a:srgbClr val="2B3A50"/>
                     </a:solidFill>
                   </a:tcPr>
                 </a:tc>
@@ -6330,7 +6330,7 @@
                       <a:r>
                         <a:rPr sz="1300" b="0" i="0">
                           <a:solidFill>
-                            <a:srgbClr val="C5D2E4"/>
+                            <a:srgbClr val="CBD5E1"/>
                           </a:solidFill>
                           <a:latin typeface="Calibri"/>
                         </a:rPr>
@@ -6340,7 +6340,7 @@
                   </a:txBody>
                   <a:tcPr anchor="ctr" marL="100584" marR="100584" marT="36576" marB="36576">
                     <a:solidFill>
-                      <a:srgbClr val="121E30"/>
+                      <a:srgbClr val="2B3A50"/>
                     </a:solidFill>
                   </a:tcPr>
                 </a:tc>
@@ -6353,7 +6353,7 @@
                       <a:r>
                         <a:rPr sz="1300" b="0" i="0">
                           <a:solidFill>
-                            <a:srgbClr val="C5D2E4"/>
+                            <a:srgbClr val="CBD5E1"/>
                           </a:solidFill>
                           <a:latin typeface="Calibri"/>
                         </a:rPr>
@@ -6363,7 +6363,7 @@
                   </a:txBody>
                   <a:tcPr anchor="ctr" marL="100584" marR="100584" marT="36576" marB="36576">
                     <a:solidFill>
-                      <a:srgbClr val="121E30"/>
+                      <a:srgbClr val="2B3A50"/>
                     </a:solidFill>
                   </a:tcPr>
                 </a:tc>
@@ -6378,7 +6378,7 @@
                       <a:r>
                         <a:rPr sz="1300" b="1" i="0">
                           <a:solidFill>
-                            <a:srgbClr val="F2F6FB"/>
+                            <a:srgbClr val="F8FAFC"/>
                           </a:solidFill>
                           <a:latin typeface="Calibri"/>
                         </a:rPr>
@@ -6388,7 +6388,7 @@
                   </a:txBody>
                   <a:tcPr anchor="ctr" marL="100584" marR="100584" marT="36576" marB="36576">
                     <a:solidFill>
-                      <a:srgbClr val="12303A"/>
+                      <a:srgbClr val="334155"/>
                     </a:solidFill>
                   </a:tcPr>
                 </a:tc>
@@ -6401,7 +6401,7 @@
                       <a:r>
                         <a:rPr sz="1300" b="1" i="0">
                           <a:solidFill>
-                            <a:srgbClr val="F2F6FB"/>
+                            <a:srgbClr val="F8FAFC"/>
                           </a:solidFill>
                           <a:latin typeface="Calibri"/>
                         </a:rPr>
@@ -6411,7 +6411,7 @@
                   </a:txBody>
                   <a:tcPr anchor="ctr" marL="100584" marR="100584" marT="36576" marB="36576">
                     <a:solidFill>
-                      <a:srgbClr val="12303A"/>
+                      <a:srgbClr val="334155"/>
                     </a:solidFill>
                   </a:tcPr>
                 </a:tc>
@@ -6424,7 +6424,7 @@
                       <a:r>
                         <a:rPr sz="1300" b="1" i="0">
                           <a:solidFill>
-                            <a:srgbClr val="F2F6FB"/>
+                            <a:srgbClr val="F8FAFC"/>
                           </a:solidFill>
                           <a:latin typeface="Calibri"/>
                         </a:rPr>
@@ -6434,7 +6434,7 @@
                   </a:txBody>
                   <a:tcPr anchor="ctr" marL="100584" marR="100584" marT="36576" marB="36576">
                     <a:solidFill>
-                      <a:srgbClr val="12303A"/>
+                      <a:srgbClr val="334155"/>
                     </a:solidFill>
                   </a:tcPr>
                 </a:tc>
@@ -6447,7 +6447,7 @@
                       <a:r>
                         <a:rPr sz="1300" b="1" i="0">
                           <a:solidFill>
-                            <a:srgbClr val="F2F6FB"/>
+                            <a:srgbClr val="F8FAFC"/>
                           </a:solidFill>
                           <a:latin typeface="Calibri"/>
                         </a:rPr>
@@ -6457,7 +6457,7 @@
                   </a:txBody>
                   <a:tcPr anchor="ctr" marL="100584" marR="100584" marT="36576" marB="36576">
                     <a:solidFill>
-                      <a:srgbClr val="12303A"/>
+                      <a:srgbClr val="334155"/>
                     </a:solidFill>
                   </a:tcPr>
                 </a:tc>
@@ -6470,7 +6470,7 @@
                       <a:r>
                         <a:rPr sz="1300" b="1" i="0">
                           <a:solidFill>
-                            <a:srgbClr val="F2F6FB"/>
+                            <a:srgbClr val="F8FAFC"/>
                           </a:solidFill>
                           <a:latin typeface="Calibri"/>
                         </a:rPr>
@@ -6480,7 +6480,7 @@
                   </a:txBody>
                   <a:tcPr anchor="ctr" marL="100584" marR="100584" marT="36576" marB="36576">
                     <a:solidFill>
-                      <a:srgbClr val="12303A"/>
+                      <a:srgbClr val="334155"/>
                     </a:solidFill>
                   </a:tcPr>
                 </a:tc>
@@ -6493,7 +6493,7 @@
                       <a:r>
                         <a:rPr sz="1300" b="1" i="0">
                           <a:solidFill>
-                            <a:srgbClr val="F2F6FB"/>
+                            <a:srgbClr val="F8FAFC"/>
                           </a:solidFill>
                           <a:latin typeface="Calibri"/>
                         </a:rPr>
@@ -6503,7 +6503,7 @@
                   </a:txBody>
                   <a:tcPr anchor="ctr" marL="100584" marR="100584" marT="36576" marB="36576">
                     <a:solidFill>
-                      <a:srgbClr val="12303A"/>
+                      <a:srgbClr val="334155"/>
                     </a:solidFill>
                   </a:tcPr>
                 </a:tc>
@@ -6518,7 +6518,7 @@
                       <a:r>
                         <a:rPr sz="1300" b="0" i="0">
                           <a:solidFill>
-                            <a:srgbClr val="C5D2E4"/>
+                            <a:srgbClr val="CBD5E1"/>
                           </a:solidFill>
                           <a:latin typeface="Calibri"/>
                         </a:rPr>
@@ -6528,7 +6528,7 @@
                   </a:txBody>
                   <a:tcPr anchor="ctr" marL="100584" marR="100584" marT="36576" marB="36576">
                     <a:solidFill>
-                      <a:srgbClr val="121E30"/>
+                      <a:srgbClr val="2B3A50"/>
                     </a:solidFill>
                   </a:tcPr>
                 </a:tc>
@@ -6541,7 +6541,7 @@
                       <a:r>
                         <a:rPr sz="1300" b="0" i="0">
                           <a:solidFill>
-                            <a:srgbClr val="C5D2E4"/>
+                            <a:srgbClr val="CBD5E1"/>
                           </a:solidFill>
                           <a:latin typeface="Calibri"/>
                         </a:rPr>
@@ -6551,7 +6551,7 @@
                   </a:txBody>
                   <a:tcPr anchor="ctr" marL="100584" marR="100584" marT="36576" marB="36576">
                     <a:solidFill>
-                      <a:srgbClr val="121E30"/>
+                      <a:srgbClr val="2B3A50"/>
                     </a:solidFill>
                   </a:tcPr>
                 </a:tc>
@@ -6564,7 +6564,7 @@
                       <a:r>
                         <a:rPr sz="1300" b="0" i="0">
                           <a:solidFill>
-                            <a:srgbClr val="C5D2E4"/>
+                            <a:srgbClr val="CBD5E1"/>
                           </a:solidFill>
                           <a:latin typeface="Calibri"/>
                         </a:rPr>
@@ -6574,7 +6574,7 @@
                   </a:txBody>
                   <a:tcPr anchor="ctr" marL="100584" marR="100584" marT="36576" marB="36576">
                     <a:solidFill>
-                      <a:srgbClr val="121E30"/>
+                      <a:srgbClr val="2B3A50"/>
                     </a:solidFill>
                   </a:tcPr>
                 </a:tc>
@@ -6587,7 +6587,7 @@
                       <a:r>
                         <a:rPr sz="1300" b="0" i="0">
                           <a:solidFill>
-                            <a:srgbClr val="C5D2E4"/>
+                            <a:srgbClr val="CBD5E1"/>
                           </a:solidFill>
                           <a:latin typeface="Calibri"/>
                         </a:rPr>
@@ -6597,7 +6597,7 @@
                   </a:txBody>
                   <a:tcPr anchor="ctr" marL="100584" marR="100584" marT="36576" marB="36576">
                     <a:solidFill>
-                      <a:srgbClr val="121E30"/>
+                      <a:srgbClr val="2B3A50"/>
                     </a:solidFill>
                   </a:tcPr>
                 </a:tc>
@@ -6610,7 +6610,7 @@
                       <a:r>
                         <a:rPr sz="1300" b="0" i="0">
                           <a:solidFill>
-                            <a:srgbClr val="C5D2E4"/>
+                            <a:srgbClr val="CBD5E1"/>
                           </a:solidFill>
                           <a:latin typeface="Calibri"/>
                         </a:rPr>
@@ -6620,7 +6620,7 @@
                   </a:txBody>
                   <a:tcPr anchor="ctr" marL="100584" marR="100584" marT="36576" marB="36576">
                     <a:solidFill>
-                      <a:srgbClr val="121E30"/>
+                      <a:srgbClr val="2B3A50"/>
                     </a:solidFill>
                   </a:tcPr>
                 </a:tc>
@@ -6633,7 +6633,7 @@
                       <a:r>
                         <a:rPr sz="1300" b="0" i="0">
                           <a:solidFill>
-                            <a:srgbClr val="C5D2E4"/>
+                            <a:srgbClr val="CBD5E1"/>
                           </a:solidFill>
                           <a:latin typeface="Calibri"/>
                         </a:rPr>
@@ -6643,7 +6643,7 @@
                   </a:txBody>
                   <a:tcPr anchor="ctr" marL="100584" marR="100584" marT="36576" marB="36576">
                     <a:solidFill>
-                      <a:srgbClr val="121E30"/>
+                      <a:srgbClr val="2B3A50"/>
                     </a:solidFill>
                   </a:tcPr>
                 </a:tc>
@@ -6658,7 +6658,7 @@
                       <a:r>
                         <a:rPr sz="1300" b="0" i="0">
                           <a:solidFill>
-                            <a:srgbClr val="C5D2E4"/>
+                            <a:srgbClr val="CBD5E1"/>
                           </a:solidFill>
                           <a:latin typeface="Calibri"/>
                         </a:rPr>
@@ -6668,7 +6668,7 @@
                   </a:txBody>
                   <a:tcPr anchor="ctr" marL="100584" marR="100584" marT="36576" marB="36576">
                     <a:solidFill>
-                      <a:srgbClr val="0E1929"/>
+                      <a:srgbClr val="243247"/>
                     </a:solidFill>
                   </a:tcPr>
                 </a:tc>
@@ -6681,7 +6681,7 @@
                       <a:r>
                         <a:rPr sz="1300" b="0" i="0">
                           <a:solidFill>
-                            <a:srgbClr val="C5D2E4"/>
+                            <a:srgbClr val="CBD5E1"/>
                           </a:solidFill>
                           <a:latin typeface="Calibri"/>
                         </a:rPr>
@@ -6691,7 +6691,7 @@
                   </a:txBody>
                   <a:tcPr anchor="ctr" marL="100584" marR="100584" marT="36576" marB="36576">
                     <a:solidFill>
-                      <a:srgbClr val="0E1929"/>
+                      <a:srgbClr val="243247"/>
                     </a:solidFill>
                   </a:tcPr>
                 </a:tc>
@@ -6704,7 +6704,7 @@
                       <a:r>
                         <a:rPr sz="1300" b="0" i="0">
                           <a:solidFill>
-                            <a:srgbClr val="C5D2E4"/>
+                            <a:srgbClr val="CBD5E1"/>
                           </a:solidFill>
                           <a:latin typeface="Calibri"/>
                         </a:rPr>
@@ -6714,7 +6714,7 @@
                   </a:txBody>
                   <a:tcPr anchor="ctr" marL="100584" marR="100584" marT="36576" marB="36576">
                     <a:solidFill>
-                      <a:srgbClr val="0E1929"/>
+                      <a:srgbClr val="243247"/>
                     </a:solidFill>
                   </a:tcPr>
                 </a:tc>
@@ -6727,7 +6727,7 @@
                       <a:r>
                         <a:rPr sz="1300" b="0" i="0">
                           <a:solidFill>
-                            <a:srgbClr val="C5D2E4"/>
+                            <a:srgbClr val="CBD5E1"/>
                           </a:solidFill>
                           <a:latin typeface="Calibri"/>
                         </a:rPr>
@@ -6737,7 +6737,7 @@
                   </a:txBody>
                   <a:tcPr anchor="ctr" marL="100584" marR="100584" marT="36576" marB="36576">
                     <a:solidFill>
-                      <a:srgbClr val="0E1929"/>
+                      <a:srgbClr val="243247"/>
                     </a:solidFill>
                   </a:tcPr>
                 </a:tc>
@@ -6750,7 +6750,7 @@
                       <a:r>
                         <a:rPr sz="1300" b="0" i="0">
                           <a:solidFill>
-                            <a:srgbClr val="C5D2E4"/>
+                            <a:srgbClr val="CBD5E1"/>
                           </a:solidFill>
                           <a:latin typeface="Calibri"/>
                         </a:rPr>
@@ -6760,7 +6760,7 @@
                   </a:txBody>
                   <a:tcPr anchor="ctr" marL="100584" marR="100584" marT="36576" marB="36576">
                     <a:solidFill>
-                      <a:srgbClr val="0E1929"/>
+                      <a:srgbClr val="243247"/>
                     </a:solidFill>
                   </a:tcPr>
                 </a:tc>
@@ -6773,7 +6773,7 @@
                       <a:r>
                         <a:rPr sz="1300" b="0" i="0">
                           <a:solidFill>
-                            <a:srgbClr val="C5D2E4"/>
+                            <a:srgbClr val="CBD5E1"/>
                           </a:solidFill>
                           <a:latin typeface="Calibri"/>
                         </a:rPr>
@@ -6783,7 +6783,7 @@
                   </a:txBody>
                   <a:tcPr anchor="ctr" marL="100584" marR="100584" marT="36576" marB="36576">
                     <a:solidFill>
-                      <a:srgbClr val="0E1929"/>
+                      <a:srgbClr val="243247"/>
                     </a:solidFill>
                   </a:tcPr>
                 </a:tc>
@@ -6830,7 +6830,7 @@
             <a:r>
               <a:rPr sz="1550" b="0" i="0">
                 <a:solidFill>
-                  <a:srgbClr val="C5D2E4"/>
+                  <a:srgbClr val="CBD5E1"/>
                 </a:solidFill>
                 <a:latin typeface="Calibri"/>
               </a:rPr>
@@ -6854,7 +6854,7 @@
             <a:r>
               <a:rPr sz="1550" b="0" i="0">
                 <a:solidFill>
-                  <a:srgbClr val="C5D2E4"/>
+                  <a:srgbClr val="CBD5E1"/>
                 </a:solidFill>
                 <a:latin typeface="Calibri"/>
               </a:rPr>
@@ -6878,7 +6878,7 @@
             <a:r>
               <a:rPr sz="1550" b="0" i="0">
                 <a:solidFill>
-                  <a:srgbClr val="C5D2E4"/>
+                  <a:srgbClr val="CBD5E1"/>
                 </a:solidFill>
                 <a:latin typeface="Calibri"/>
               </a:rPr>
@@ -6901,7 +6901,7 @@
     <p:bg>
       <p:bgPr>
         <a:solidFill>
-          <a:srgbClr val="0B1220"/>
+          <a:srgbClr val="1E293B"/>
         </a:solidFill>
         <a:effectLst/>
       </p:bgPr>
@@ -6977,7 +6977,7 @@
             <a:r>
               <a:rPr sz="2900" b="1" i="0">
                 <a:solidFill>
-                  <a:srgbClr val="F2F6FB"/>
+                  <a:srgbClr val="F8FAFC"/>
                 </a:solidFill>
                 <a:latin typeface="Calibri Light"/>
               </a:rPr>
@@ -7056,7 +7056,7 @@
             <a:r>
               <a:rPr sz="1100" b="0" i="0">
                 <a:solidFill>
-                  <a:srgbClr val="55688A"/>
+                  <a:srgbClr val="8296B0"/>
                 </a:solidFill>
                 <a:latin typeface="Calibri"/>
               </a:rPr>
@@ -7089,7 +7089,7 @@
           </a:prstGeom>
           <a:ln w="9525">
             <a:solidFill>
-              <a:srgbClr val="253750"/>
+              <a:srgbClr val="475569"/>
             </a:solidFill>
           </a:ln>
         </p:spPr>
@@ -7132,7 +7132,7 @@
             <a:r>
               <a:rPr sz="1600" b="1" i="0">
                 <a:solidFill>
-                  <a:srgbClr val="F2F6FB"/>
+                  <a:srgbClr val="F8FAFC"/>
                 </a:solidFill>
                 <a:latin typeface="Calibri"/>
               </a:rPr>
@@ -7141,7 +7141,7 @@
             <a:r>
               <a:rPr sz="1600" b="0" i="0">
                 <a:solidFill>
-                  <a:srgbClr val="C5D2E4"/>
+                  <a:srgbClr val="CBD5E1"/>
                 </a:solidFill>
                 <a:latin typeface="Calibri"/>
               </a:rPr>
@@ -7165,7 +7165,7 @@
             <a:r>
               <a:rPr sz="1600" b="1" i="0">
                 <a:solidFill>
-                  <a:srgbClr val="F2F6FB"/>
+                  <a:srgbClr val="F8FAFC"/>
                 </a:solidFill>
                 <a:latin typeface="Calibri"/>
               </a:rPr>
@@ -7174,7 +7174,7 @@
             <a:r>
               <a:rPr sz="1600" b="0" i="0">
                 <a:solidFill>
-                  <a:srgbClr val="C5D2E4"/>
+                  <a:srgbClr val="CBD5E1"/>
                 </a:solidFill>
                 <a:latin typeface="Calibri"/>
               </a:rPr>
@@ -7198,7 +7198,7 @@
             <a:r>
               <a:rPr sz="1600" b="0" i="0">
                 <a:solidFill>
-                  <a:srgbClr val="C5D2E4"/>
+                  <a:srgbClr val="CBD5E1"/>
                 </a:solidFill>
                 <a:latin typeface="Calibri"/>
               </a:rPr>
@@ -7222,7 +7222,7 @@
             <a:r>
               <a:rPr sz="1600" b="0" i="0">
                 <a:solidFill>
-                  <a:srgbClr val="C5D2E4"/>
+                  <a:srgbClr val="CBD5E1"/>
                 </a:solidFill>
                 <a:latin typeface="Calibri"/>
               </a:rPr>
@@ -7245,7 +7245,7 @@
     <p:bg>
       <p:bgPr>
         <a:solidFill>
-          <a:srgbClr val="0B1220"/>
+          <a:srgbClr val="1E293B"/>
         </a:solidFill>
         <a:effectLst/>
       </p:bgPr>
@@ -7321,7 +7321,7 @@
             <a:r>
               <a:rPr sz="2900" b="1" i="0">
                 <a:solidFill>
-                  <a:srgbClr val="F2F6FB"/>
+                  <a:srgbClr val="F8FAFC"/>
                 </a:solidFill>
                 <a:latin typeface="Calibri Light"/>
               </a:rPr>
@@ -7400,7 +7400,7 @@
             <a:r>
               <a:rPr sz="1100" b="0" i="0">
                 <a:solidFill>
-                  <a:srgbClr val="55688A"/>
+                  <a:srgbClr val="8296B0"/>
                 </a:solidFill>
                 <a:latin typeface="Calibri"/>
               </a:rPr>
@@ -7454,7 +7454,7 @@
                   </a:txBody>
                   <a:tcPr anchor="ctr" marL="100584" marR="100584" marT="36576" marB="36576">
                     <a:solidFill>
-                      <a:srgbClr val="12303A"/>
+                      <a:srgbClr val="334155"/>
                     </a:solidFill>
                   </a:tcPr>
                 </a:tc>
@@ -7477,7 +7477,7 @@
                   </a:txBody>
                   <a:tcPr anchor="ctr" marL="100584" marR="100584" marT="36576" marB="36576">
                     <a:solidFill>
-                      <a:srgbClr val="12303A"/>
+                      <a:srgbClr val="334155"/>
                     </a:solidFill>
                   </a:tcPr>
                 </a:tc>
@@ -7500,7 +7500,7 @@
                   </a:txBody>
                   <a:tcPr anchor="ctr" marL="100584" marR="100584" marT="36576" marB="36576">
                     <a:solidFill>
-                      <a:srgbClr val="12303A"/>
+                      <a:srgbClr val="334155"/>
                     </a:solidFill>
                   </a:tcPr>
                 </a:tc>
@@ -7523,7 +7523,7 @@
                   </a:txBody>
                   <a:tcPr anchor="ctr" marL="100584" marR="100584" marT="36576" marB="36576">
                     <a:solidFill>
-                      <a:srgbClr val="12303A"/>
+                      <a:srgbClr val="334155"/>
                     </a:solidFill>
                   </a:tcPr>
                 </a:tc>
@@ -7546,7 +7546,7 @@
                   </a:txBody>
                   <a:tcPr anchor="ctr" marL="100584" marR="100584" marT="36576" marB="36576">
                     <a:solidFill>
-                      <a:srgbClr val="12303A"/>
+                      <a:srgbClr val="334155"/>
                     </a:solidFill>
                   </a:tcPr>
                 </a:tc>
@@ -7561,7 +7561,7 @@
                       <a:r>
                         <a:rPr sz="1400" b="0" i="0">
                           <a:solidFill>
-                            <a:srgbClr val="C5D2E4"/>
+                            <a:srgbClr val="CBD5E1"/>
                           </a:solidFill>
                           <a:latin typeface="Calibri"/>
                         </a:rPr>
@@ -7571,7 +7571,7 @@
                   </a:txBody>
                   <a:tcPr anchor="ctr" marL="100584" marR="100584" marT="36576" marB="36576">
                     <a:solidFill>
-                      <a:srgbClr val="0E1929"/>
+                      <a:srgbClr val="243247"/>
                     </a:solidFill>
                   </a:tcPr>
                 </a:tc>
@@ -7584,7 +7584,7 @@
                       <a:r>
                         <a:rPr sz="1400" b="0" i="0">
                           <a:solidFill>
-                            <a:srgbClr val="C5D2E4"/>
+                            <a:srgbClr val="CBD5E1"/>
                           </a:solidFill>
                           <a:latin typeface="Calibri"/>
                         </a:rPr>
@@ -7594,7 +7594,7 @@
                   </a:txBody>
                   <a:tcPr anchor="ctr" marL="100584" marR="100584" marT="36576" marB="36576">
                     <a:solidFill>
-                      <a:srgbClr val="0E1929"/>
+                      <a:srgbClr val="243247"/>
                     </a:solidFill>
                   </a:tcPr>
                 </a:tc>
@@ -7607,7 +7607,7 @@
                       <a:r>
                         <a:rPr sz="1400" b="0" i="0">
                           <a:solidFill>
-                            <a:srgbClr val="C5D2E4"/>
+                            <a:srgbClr val="CBD5E1"/>
                           </a:solidFill>
                           <a:latin typeface="Calibri"/>
                         </a:rPr>
@@ -7617,7 +7617,7 @@
                   </a:txBody>
                   <a:tcPr anchor="ctr" marL="100584" marR="100584" marT="36576" marB="36576">
                     <a:solidFill>
-                      <a:srgbClr val="0E1929"/>
+                      <a:srgbClr val="243247"/>
                     </a:solidFill>
                   </a:tcPr>
                 </a:tc>
@@ -7630,7 +7630,7 @@
                       <a:r>
                         <a:rPr sz="1400" b="0" i="0">
                           <a:solidFill>
-                            <a:srgbClr val="C5D2E4"/>
+                            <a:srgbClr val="CBD5E1"/>
                           </a:solidFill>
                           <a:latin typeface="Calibri"/>
                         </a:rPr>
@@ -7640,7 +7640,7 @@
                   </a:txBody>
                   <a:tcPr anchor="ctr" marL="100584" marR="100584" marT="36576" marB="36576">
                     <a:solidFill>
-                      <a:srgbClr val="0E1929"/>
+                      <a:srgbClr val="243247"/>
                     </a:solidFill>
                   </a:tcPr>
                 </a:tc>
@@ -7653,7 +7653,7 @@
                       <a:r>
                         <a:rPr sz="1400" b="0" i="0">
                           <a:solidFill>
-                            <a:srgbClr val="C5D2E4"/>
+                            <a:srgbClr val="CBD5E1"/>
                           </a:solidFill>
                           <a:latin typeface="Calibri"/>
                         </a:rPr>
@@ -7663,7 +7663,7 @@
                   </a:txBody>
                   <a:tcPr anchor="ctr" marL="100584" marR="100584" marT="36576" marB="36576">
                     <a:solidFill>
-                      <a:srgbClr val="0E1929"/>
+                      <a:srgbClr val="243247"/>
                     </a:solidFill>
                   </a:tcPr>
                 </a:tc>
@@ -7678,7 +7678,7 @@
                       <a:r>
                         <a:rPr sz="1400" b="0" i="0">
                           <a:solidFill>
-                            <a:srgbClr val="C5D2E4"/>
+                            <a:srgbClr val="CBD5E1"/>
                           </a:solidFill>
                           <a:latin typeface="Calibri"/>
                         </a:rPr>
@@ -7688,7 +7688,7 @@
                   </a:txBody>
                   <a:tcPr anchor="ctr" marL="100584" marR="100584" marT="36576" marB="36576">
                     <a:solidFill>
-                      <a:srgbClr val="121E30"/>
+                      <a:srgbClr val="2B3A50"/>
                     </a:solidFill>
                   </a:tcPr>
                 </a:tc>
@@ -7701,7 +7701,7 @@
                       <a:r>
                         <a:rPr sz="1400" b="0" i="0">
                           <a:solidFill>
-                            <a:srgbClr val="C5D2E4"/>
+                            <a:srgbClr val="CBD5E1"/>
                           </a:solidFill>
                           <a:latin typeface="Calibri"/>
                         </a:rPr>
@@ -7711,7 +7711,7 @@
                   </a:txBody>
                   <a:tcPr anchor="ctr" marL="100584" marR="100584" marT="36576" marB="36576">
                     <a:solidFill>
-                      <a:srgbClr val="121E30"/>
+                      <a:srgbClr val="2B3A50"/>
                     </a:solidFill>
                   </a:tcPr>
                 </a:tc>
@@ -7724,7 +7724,7 @@
                       <a:r>
                         <a:rPr sz="1400" b="0" i="0">
                           <a:solidFill>
-                            <a:srgbClr val="C5D2E4"/>
+                            <a:srgbClr val="CBD5E1"/>
                           </a:solidFill>
                           <a:latin typeface="Calibri"/>
                         </a:rPr>
@@ -7734,7 +7734,7 @@
                   </a:txBody>
                   <a:tcPr anchor="ctr" marL="100584" marR="100584" marT="36576" marB="36576">
                     <a:solidFill>
-                      <a:srgbClr val="121E30"/>
+                      <a:srgbClr val="2B3A50"/>
                     </a:solidFill>
                   </a:tcPr>
                 </a:tc>
@@ -7747,7 +7747,7 @@
                       <a:r>
                         <a:rPr sz="1400" b="0" i="0">
                           <a:solidFill>
-                            <a:srgbClr val="C5D2E4"/>
+                            <a:srgbClr val="CBD5E1"/>
                           </a:solidFill>
                           <a:latin typeface="Calibri"/>
                         </a:rPr>
@@ -7757,7 +7757,7 @@
                   </a:txBody>
                   <a:tcPr anchor="ctr" marL="100584" marR="100584" marT="36576" marB="36576">
                     <a:solidFill>
-                      <a:srgbClr val="121E30"/>
+                      <a:srgbClr val="2B3A50"/>
                     </a:solidFill>
                   </a:tcPr>
                 </a:tc>
@@ -7770,7 +7770,7 @@
                       <a:r>
                         <a:rPr sz="1400" b="0" i="0">
                           <a:solidFill>
-                            <a:srgbClr val="C5D2E4"/>
+                            <a:srgbClr val="CBD5E1"/>
                           </a:solidFill>
                           <a:latin typeface="Calibri"/>
                         </a:rPr>
@@ -7780,7 +7780,7 @@
                   </a:txBody>
                   <a:tcPr anchor="ctr" marL="100584" marR="100584" marT="36576" marB="36576">
                     <a:solidFill>
-                      <a:srgbClr val="121E30"/>
+                      <a:srgbClr val="2B3A50"/>
                     </a:solidFill>
                   </a:tcPr>
                 </a:tc>
@@ -7795,7 +7795,7 @@
                       <a:r>
                         <a:rPr sz="1400" b="0" i="0">
                           <a:solidFill>
-                            <a:srgbClr val="C5D2E4"/>
+                            <a:srgbClr val="CBD5E1"/>
                           </a:solidFill>
                           <a:latin typeface="Calibri"/>
                         </a:rPr>
@@ -7805,7 +7805,7 @@
                   </a:txBody>
                   <a:tcPr anchor="ctr" marL="100584" marR="100584" marT="36576" marB="36576">
                     <a:solidFill>
-                      <a:srgbClr val="0E1929"/>
+                      <a:srgbClr val="243247"/>
                     </a:solidFill>
                   </a:tcPr>
                 </a:tc>
@@ -7818,7 +7818,7 @@
                       <a:r>
                         <a:rPr sz="1400" b="0" i="0">
                           <a:solidFill>
-                            <a:srgbClr val="C5D2E4"/>
+                            <a:srgbClr val="CBD5E1"/>
                           </a:solidFill>
                           <a:latin typeface="Calibri"/>
                         </a:rPr>
@@ -7828,7 +7828,7 @@
                   </a:txBody>
                   <a:tcPr anchor="ctr" marL="100584" marR="100584" marT="36576" marB="36576">
                     <a:solidFill>
-                      <a:srgbClr val="0E1929"/>
+                      <a:srgbClr val="243247"/>
                     </a:solidFill>
                   </a:tcPr>
                 </a:tc>
@@ -7841,7 +7841,7 @@
                       <a:r>
                         <a:rPr sz="1400" b="0" i="0">
                           <a:solidFill>
-                            <a:srgbClr val="C5D2E4"/>
+                            <a:srgbClr val="CBD5E1"/>
                           </a:solidFill>
                           <a:latin typeface="Calibri"/>
                         </a:rPr>
@@ -7851,7 +7851,7 @@
                   </a:txBody>
                   <a:tcPr anchor="ctr" marL="100584" marR="100584" marT="36576" marB="36576">
                     <a:solidFill>
-                      <a:srgbClr val="0E1929"/>
+                      <a:srgbClr val="243247"/>
                     </a:solidFill>
                   </a:tcPr>
                 </a:tc>
@@ -7864,7 +7864,7 @@
                       <a:r>
                         <a:rPr sz="1400" b="0" i="0">
                           <a:solidFill>
-                            <a:srgbClr val="C5D2E4"/>
+                            <a:srgbClr val="CBD5E1"/>
                           </a:solidFill>
                           <a:latin typeface="Calibri"/>
                         </a:rPr>
@@ -7874,7 +7874,7 @@
                   </a:txBody>
                   <a:tcPr anchor="ctr" marL="100584" marR="100584" marT="36576" marB="36576">
                     <a:solidFill>
-                      <a:srgbClr val="0E1929"/>
+                      <a:srgbClr val="243247"/>
                     </a:solidFill>
                   </a:tcPr>
                 </a:tc>
@@ -7887,7 +7887,7 @@
                       <a:r>
                         <a:rPr sz="1400" b="0" i="0">
                           <a:solidFill>
-                            <a:srgbClr val="C5D2E4"/>
+                            <a:srgbClr val="CBD5E1"/>
                           </a:solidFill>
                           <a:latin typeface="Calibri"/>
                         </a:rPr>
@@ -7897,7 +7897,7 @@
                   </a:txBody>
                   <a:tcPr anchor="ctr" marL="100584" marR="100584" marT="36576" marB="36576">
                     <a:solidFill>
-                      <a:srgbClr val="0E1929"/>
+                      <a:srgbClr val="243247"/>
                     </a:solidFill>
                   </a:tcPr>
                 </a:tc>
@@ -7912,7 +7912,7 @@
                       <a:r>
                         <a:rPr sz="1400" b="0" i="0">
                           <a:solidFill>
-                            <a:srgbClr val="C5D2E4"/>
+                            <a:srgbClr val="CBD5E1"/>
                           </a:solidFill>
                           <a:latin typeface="Calibri"/>
                         </a:rPr>
@@ -7922,7 +7922,7 @@
                   </a:txBody>
                   <a:tcPr anchor="ctr" marL="100584" marR="100584" marT="36576" marB="36576">
                     <a:solidFill>
-                      <a:srgbClr val="121E30"/>
+                      <a:srgbClr val="2B3A50"/>
                     </a:solidFill>
                   </a:tcPr>
                 </a:tc>
@@ -7935,7 +7935,7 @@
                       <a:r>
                         <a:rPr sz="1400" b="0" i="0">
                           <a:solidFill>
-                            <a:srgbClr val="C5D2E4"/>
+                            <a:srgbClr val="CBD5E1"/>
                           </a:solidFill>
                           <a:latin typeface="Calibri"/>
                         </a:rPr>
@@ -7945,7 +7945,7 @@
                   </a:txBody>
                   <a:tcPr anchor="ctr" marL="100584" marR="100584" marT="36576" marB="36576">
                     <a:solidFill>
-                      <a:srgbClr val="121E30"/>
+                      <a:srgbClr val="2B3A50"/>
                     </a:solidFill>
                   </a:tcPr>
                 </a:tc>
@@ -7958,7 +7958,7 @@
                       <a:r>
                         <a:rPr sz="1400" b="0" i="0">
                           <a:solidFill>
-                            <a:srgbClr val="C5D2E4"/>
+                            <a:srgbClr val="CBD5E1"/>
                           </a:solidFill>
                           <a:latin typeface="Calibri"/>
                         </a:rPr>
@@ -7968,7 +7968,7 @@
                   </a:txBody>
                   <a:tcPr anchor="ctr" marL="100584" marR="100584" marT="36576" marB="36576">
                     <a:solidFill>
-                      <a:srgbClr val="121E30"/>
+                      <a:srgbClr val="2B3A50"/>
                     </a:solidFill>
                   </a:tcPr>
                 </a:tc>
@@ -7981,7 +7981,7 @@
                       <a:r>
                         <a:rPr sz="1400" b="0" i="0">
                           <a:solidFill>
-                            <a:srgbClr val="C5D2E4"/>
+                            <a:srgbClr val="CBD5E1"/>
                           </a:solidFill>
                           <a:latin typeface="Calibri"/>
                         </a:rPr>
@@ -7991,7 +7991,7 @@
                   </a:txBody>
                   <a:tcPr anchor="ctr" marL="100584" marR="100584" marT="36576" marB="36576">
                     <a:solidFill>
-                      <a:srgbClr val="121E30"/>
+                      <a:srgbClr val="2B3A50"/>
                     </a:solidFill>
                   </a:tcPr>
                 </a:tc>
@@ -8004,7 +8004,7 @@
                       <a:r>
                         <a:rPr sz="1400" b="0" i="0">
                           <a:solidFill>
-                            <a:srgbClr val="C5D2E4"/>
+                            <a:srgbClr val="CBD5E1"/>
                           </a:solidFill>
                           <a:latin typeface="Calibri"/>
                         </a:rPr>
@@ -8014,7 +8014,7 @@
                   </a:txBody>
                   <a:tcPr anchor="ctr" marL="100584" marR="100584" marT="36576" marB="36576">
                     <a:solidFill>
-                      <a:srgbClr val="121E30"/>
+                      <a:srgbClr val="2B3A50"/>
                     </a:solidFill>
                   </a:tcPr>
                 </a:tc>
@@ -8029,7 +8029,7 @@
                       <a:r>
                         <a:rPr sz="1400" b="0" i="0">
                           <a:solidFill>
-                            <a:srgbClr val="C5D2E4"/>
+                            <a:srgbClr val="CBD5E1"/>
                           </a:solidFill>
                           <a:latin typeface="Calibri"/>
                         </a:rPr>
@@ -8039,7 +8039,7 @@
                   </a:txBody>
                   <a:tcPr anchor="ctr" marL="100584" marR="100584" marT="36576" marB="36576">
                     <a:solidFill>
-                      <a:srgbClr val="0E1929"/>
+                      <a:srgbClr val="243247"/>
                     </a:solidFill>
                   </a:tcPr>
                 </a:tc>
@@ -8052,7 +8052,7 @@
                       <a:r>
                         <a:rPr sz="1400" b="0" i="0">
                           <a:solidFill>
-                            <a:srgbClr val="C5D2E4"/>
+                            <a:srgbClr val="CBD5E1"/>
                           </a:solidFill>
                           <a:latin typeface="Calibri"/>
                         </a:rPr>
@@ -8062,7 +8062,7 @@
                   </a:txBody>
                   <a:tcPr anchor="ctr" marL="100584" marR="100584" marT="36576" marB="36576">
                     <a:solidFill>
-                      <a:srgbClr val="0E1929"/>
+                      <a:srgbClr val="243247"/>
                     </a:solidFill>
                   </a:tcPr>
                 </a:tc>
@@ -8075,7 +8075,7 @@
                       <a:r>
                         <a:rPr sz="1400" b="0" i="0">
                           <a:solidFill>
-                            <a:srgbClr val="C5D2E4"/>
+                            <a:srgbClr val="CBD5E1"/>
                           </a:solidFill>
                           <a:latin typeface="Calibri"/>
                         </a:rPr>
@@ -8085,7 +8085,7 @@
                   </a:txBody>
                   <a:tcPr anchor="ctr" marL="100584" marR="100584" marT="36576" marB="36576">
                     <a:solidFill>
-                      <a:srgbClr val="0E1929"/>
+                      <a:srgbClr val="243247"/>
                     </a:solidFill>
                   </a:tcPr>
                 </a:tc>
@@ -8098,7 +8098,7 @@
                       <a:r>
                         <a:rPr sz="1400" b="0" i="0">
                           <a:solidFill>
-                            <a:srgbClr val="C5D2E4"/>
+                            <a:srgbClr val="CBD5E1"/>
                           </a:solidFill>
                           <a:latin typeface="Calibri"/>
                         </a:rPr>
@@ -8108,7 +8108,7 @@
                   </a:txBody>
                   <a:tcPr anchor="ctr" marL="100584" marR="100584" marT="36576" marB="36576">
                     <a:solidFill>
-                      <a:srgbClr val="0E1929"/>
+                      <a:srgbClr val="243247"/>
                     </a:solidFill>
                   </a:tcPr>
                 </a:tc>
@@ -8121,7 +8121,7 @@
                       <a:r>
                         <a:rPr sz="1400" b="0" i="0">
                           <a:solidFill>
-                            <a:srgbClr val="C5D2E4"/>
+                            <a:srgbClr val="CBD5E1"/>
                           </a:solidFill>
                           <a:latin typeface="Calibri"/>
                         </a:rPr>
@@ -8131,7 +8131,7 @@
                   </a:txBody>
                   <a:tcPr anchor="ctr" marL="100584" marR="100584" marT="36576" marB="36576">
                     <a:solidFill>
-                      <a:srgbClr val="0E1929"/>
+                      <a:srgbClr val="243247"/>
                     </a:solidFill>
                   </a:tcPr>
                 </a:tc>
@@ -8146,7 +8146,7 @@
                       <a:r>
                         <a:rPr sz="1400" b="0" i="0">
                           <a:solidFill>
-                            <a:srgbClr val="C5D2E4"/>
+                            <a:srgbClr val="CBD5E1"/>
                           </a:solidFill>
                           <a:latin typeface="Calibri"/>
                         </a:rPr>
@@ -8156,7 +8156,7 @@
                   </a:txBody>
                   <a:tcPr anchor="ctr" marL="100584" marR="100584" marT="36576" marB="36576">
                     <a:solidFill>
-                      <a:srgbClr val="121E30"/>
+                      <a:srgbClr val="2B3A50"/>
                     </a:solidFill>
                   </a:tcPr>
                 </a:tc>
@@ -8169,7 +8169,7 @@
                       <a:r>
                         <a:rPr sz="1400" b="0" i="0">
                           <a:solidFill>
-                            <a:srgbClr val="C5D2E4"/>
+                            <a:srgbClr val="CBD5E1"/>
                           </a:solidFill>
                           <a:latin typeface="Calibri"/>
                         </a:rPr>
@@ -8179,7 +8179,7 @@
                   </a:txBody>
                   <a:tcPr anchor="ctr" marL="100584" marR="100584" marT="36576" marB="36576">
                     <a:solidFill>
-                      <a:srgbClr val="121E30"/>
+                      <a:srgbClr val="2B3A50"/>
                     </a:solidFill>
                   </a:tcPr>
                 </a:tc>
@@ -8192,7 +8192,7 @@
                       <a:r>
                         <a:rPr sz="1400" b="0" i="0">
                           <a:solidFill>
-                            <a:srgbClr val="C5D2E4"/>
+                            <a:srgbClr val="CBD5E1"/>
                           </a:solidFill>
                           <a:latin typeface="Calibri"/>
                         </a:rPr>
@@ -8202,7 +8202,7 @@
                   </a:txBody>
                   <a:tcPr anchor="ctr" marL="100584" marR="100584" marT="36576" marB="36576">
                     <a:solidFill>
-                      <a:srgbClr val="121E30"/>
+                      <a:srgbClr val="2B3A50"/>
                     </a:solidFill>
                   </a:tcPr>
                 </a:tc>
@@ -8215,7 +8215,7 @@
                       <a:r>
                         <a:rPr sz="1400" b="0" i="0">
                           <a:solidFill>
-                            <a:srgbClr val="C5D2E4"/>
+                            <a:srgbClr val="CBD5E1"/>
                           </a:solidFill>
                           <a:latin typeface="Calibri"/>
                         </a:rPr>
@@ -8225,7 +8225,7 @@
                   </a:txBody>
                   <a:tcPr anchor="ctr" marL="100584" marR="100584" marT="36576" marB="36576">
                     <a:solidFill>
-                      <a:srgbClr val="121E30"/>
+                      <a:srgbClr val="2B3A50"/>
                     </a:solidFill>
                   </a:tcPr>
                 </a:tc>
@@ -8238,7 +8238,7 @@
                       <a:r>
                         <a:rPr sz="1400" b="0" i="0">
                           <a:solidFill>
-                            <a:srgbClr val="C5D2E4"/>
+                            <a:srgbClr val="CBD5E1"/>
                           </a:solidFill>
                           <a:latin typeface="Calibri"/>
                         </a:rPr>
@@ -8248,7 +8248,7 @@
                   </a:txBody>
                   <a:tcPr anchor="ctr" marL="100584" marR="100584" marT="36576" marB="36576">
                     <a:solidFill>
-                      <a:srgbClr val="121E30"/>
+                      <a:srgbClr val="2B3A50"/>
                     </a:solidFill>
                   </a:tcPr>
                 </a:tc>
@@ -8263,7 +8263,7 @@
                       <a:r>
                         <a:rPr sz="1400" b="0" i="0">
                           <a:solidFill>
-                            <a:srgbClr val="C5D2E4"/>
+                            <a:srgbClr val="CBD5E1"/>
                           </a:solidFill>
                           <a:latin typeface="Calibri"/>
                         </a:rPr>
@@ -8273,7 +8273,7 @@
                   </a:txBody>
                   <a:tcPr anchor="ctr" marL="100584" marR="100584" marT="36576" marB="36576">
                     <a:solidFill>
-                      <a:srgbClr val="0E1929"/>
+                      <a:srgbClr val="243247"/>
                     </a:solidFill>
                   </a:tcPr>
                 </a:tc>
@@ -8286,7 +8286,7 @@
                       <a:r>
                         <a:rPr sz="1400" b="0" i="0">
                           <a:solidFill>
-                            <a:srgbClr val="C5D2E4"/>
+                            <a:srgbClr val="CBD5E1"/>
                           </a:solidFill>
                           <a:latin typeface="Calibri"/>
                         </a:rPr>
@@ -8296,7 +8296,7 @@
                   </a:txBody>
                   <a:tcPr anchor="ctr" marL="100584" marR="100584" marT="36576" marB="36576">
                     <a:solidFill>
-                      <a:srgbClr val="0E1929"/>
+                      <a:srgbClr val="243247"/>
                     </a:solidFill>
                   </a:tcPr>
                 </a:tc>
@@ -8309,7 +8309,7 @@
                       <a:r>
                         <a:rPr sz="1400" b="0" i="0">
                           <a:solidFill>
-                            <a:srgbClr val="C5D2E4"/>
+                            <a:srgbClr val="CBD5E1"/>
                           </a:solidFill>
                           <a:latin typeface="Calibri"/>
                         </a:rPr>
@@ -8319,7 +8319,7 @@
                   </a:txBody>
                   <a:tcPr anchor="ctr" marL="100584" marR="100584" marT="36576" marB="36576">
                     <a:solidFill>
-                      <a:srgbClr val="0E1929"/>
+                      <a:srgbClr val="243247"/>
                     </a:solidFill>
                   </a:tcPr>
                 </a:tc>
@@ -8332,7 +8332,7 @@
                       <a:r>
                         <a:rPr sz="1400" b="0" i="0">
                           <a:solidFill>
-                            <a:srgbClr val="C5D2E4"/>
+                            <a:srgbClr val="CBD5E1"/>
                           </a:solidFill>
                           <a:latin typeface="Calibri"/>
                         </a:rPr>
@@ -8342,7 +8342,7 @@
                   </a:txBody>
                   <a:tcPr anchor="ctr" marL="100584" marR="100584" marT="36576" marB="36576">
                     <a:solidFill>
-                      <a:srgbClr val="0E1929"/>
+                      <a:srgbClr val="243247"/>
                     </a:solidFill>
                   </a:tcPr>
                 </a:tc>
@@ -8355,7 +8355,7 @@
                       <a:r>
                         <a:rPr sz="1400" b="0" i="0">
                           <a:solidFill>
-                            <a:srgbClr val="C5D2E4"/>
+                            <a:srgbClr val="CBD5E1"/>
                           </a:solidFill>
                           <a:latin typeface="Calibri"/>
                         </a:rPr>
@@ -8365,7 +8365,7 @@
                   </a:txBody>
                   <a:tcPr anchor="ctr" marL="100584" marR="100584" marT="36576" marB="36576">
                     <a:solidFill>
-                      <a:srgbClr val="0E1929"/>
+                      <a:srgbClr val="243247"/>
                     </a:solidFill>
                   </a:tcPr>
                 </a:tc>
@@ -8380,7 +8380,7 @@
                       <a:r>
                         <a:rPr sz="1400" b="0" i="0">
                           <a:solidFill>
-                            <a:srgbClr val="C5D2E4"/>
+                            <a:srgbClr val="CBD5E1"/>
                           </a:solidFill>
                           <a:latin typeface="Calibri"/>
                         </a:rPr>
@@ -8390,7 +8390,7 @@
                   </a:txBody>
                   <a:tcPr anchor="ctr" marL="100584" marR="100584" marT="36576" marB="36576">
                     <a:solidFill>
-                      <a:srgbClr val="121E30"/>
+                      <a:srgbClr val="2B3A50"/>
                     </a:solidFill>
                   </a:tcPr>
                 </a:tc>
@@ -8403,7 +8403,7 @@
                       <a:r>
                         <a:rPr sz="1400" b="0" i="0">
                           <a:solidFill>
-                            <a:srgbClr val="C5D2E4"/>
+                            <a:srgbClr val="CBD5E1"/>
                           </a:solidFill>
                           <a:latin typeface="Calibri"/>
                         </a:rPr>
@@ -8413,7 +8413,7 @@
                   </a:txBody>
                   <a:tcPr anchor="ctr" marL="100584" marR="100584" marT="36576" marB="36576">
                     <a:solidFill>
-                      <a:srgbClr val="121E30"/>
+                      <a:srgbClr val="2B3A50"/>
                     </a:solidFill>
                   </a:tcPr>
                 </a:tc>
@@ -8426,7 +8426,7 @@
                       <a:r>
                         <a:rPr sz="1400" b="0" i="0">
                           <a:solidFill>
-                            <a:srgbClr val="C5D2E4"/>
+                            <a:srgbClr val="CBD5E1"/>
                           </a:solidFill>
                           <a:latin typeface="Calibri"/>
                         </a:rPr>
@@ -8436,7 +8436,7 @@
                   </a:txBody>
                   <a:tcPr anchor="ctr" marL="100584" marR="100584" marT="36576" marB="36576">
                     <a:solidFill>
-                      <a:srgbClr val="121E30"/>
+                      <a:srgbClr val="2B3A50"/>
                     </a:solidFill>
                   </a:tcPr>
                 </a:tc>
@@ -8449,7 +8449,7 @@
                       <a:r>
                         <a:rPr sz="1400" b="0" i="0">
                           <a:solidFill>
-                            <a:srgbClr val="C5D2E4"/>
+                            <a:srgbClr val="CBD5E1"/>
                           </a:solidFill>
                           <a:latin typeface="Calibri"/>
                         </a:rPr>
@@ -8459,7 +8459,7 @@
                   </a:txBody>
                   <a:tcPr anchor="ctr" marL="100584" marR="100584" marT="36576" marB="36576">
                     <a:solidFill>
-                      <a:srgbClr val="121E30"/>
+                      <a:srgbClr val="2B3A50"/>
                     </a:solidFill>
                   </a:tcPr>
                 </a:tc>
@@ -8472,7 +8472,7 @@
                       <a:r>
                         <a:rPr sz="1400" b="0" i="0">
                           <a:solidFill>
-                            <a:srgbClr val="C5D2E4"/>
+                            <a:srgbClr val="CBD5E1"/>
                           </a:solidFill>
                           <a:latin typeface="Calibri"/>
                         </a:rPr>
@@ -8482,7 +8482,7 @@
                   </a:txBody>
                   <a:tcPr anchor="ctr" marL="100584" marR="100584" marT="36576" marB="36576">
                     <a:solidFill>
-                      <a:srgbClr val="121E30"/>
+                      <a:srgbClr val="2B3A50"/>
                     </a:solidFill>
                   </a:tcPr>
                 </a:tc>
@@ -8529,7 +8529,7 @@
             <a:r>
               <a:rPr sz="1550" b="0" i="0">
                 <a:solidFill>
-                  <a:srgbClr val="C5D2E4"/>
+                  <a:srgbClr val="CBD5E1"/>
                 </a:solidFill>
                 <a:latin typeface="Calibri"/>
               </a:rPr>
@@ -8553,7 +8553,7 @@
             <a:r>
               <a:rPr sz="1550" b="0" i="0">
                 <a:solidFill>
-                  <a:srgbClr val="C5D2E4"/>
+                  <a:srgbClr val="CBD5E1"/>
                 </a:solidFill>
                 <a:latin typeface="Calibri"/>
               </a:rPr>
@@ -8577,7 +8577,7 @@
             <a:r>
               <a:rPr sz="1550" b="0" i="0">
                 <a:solidFill>
-                  <a:srgbClr val="C5D2E4"/>
+                  <a:srgbClr val="CBD5E1"/>
                 </a:solidFill>
                 <a:latin typeface="Calibri"/>
               </a:rPr>
@@ -8600,7 +8600,7 @@
     <p:bg>
       <p:bgPr>
         <a:solidFill>
-          <a:srgbClr val="0B1220"/>
+          <a:srgbClr val="1E293B"/>
         </a:solidFill>
         <a:effectLst/>
       </p:bgPr>
@@ -8676,7 +8676,7 @@
             <a:r>
               <a:rPr sz="2900" b="1" i="0">
                 <a:solidFill>
-                  <a:srgbClr val="F2F6FB"/>
+                  <a:srgbClr val="F8FAFC"/>
                 </a:solidFill>
                 <a:latin typeface="Calibri Light"/>
               </a:rPr>
@@ -8755,7 +8755,7 @@
             <a:r>
               <a:rPr sz="1100" b="0" i="0">
                 <a:solidFill>
-                  <a:srgbClr val="55688A"/>
+                  <a:srgbClr val="8296B0"/>
                 </a:solidFill>
                 <a:latin typeface="Calibri"/>
               </a:rPr>
@@ -8802,7 +8802,7 @@
             <a:r>
               <a:rPr sz="1750" b="0" i="0">
                 <a:solidFill>
-                  <a:srgbClr val="C5D2E4"/>
+                  <a:srgbClr val="CBD5E1"/>
                 </a:solidFill>
                 <a:latin typeface="Calibri"/>
               </a:rPr>
@@ -8826,7 +8826,7 @@
             <a:r>
               <a:rPr sz="1750" b="0" i="0">
                 <a:solidFill>
-                  <a:srgbClr val="C5D2E4"/>
+                  <a:srgbClr val="CBD5E1"/>
                 </a:solidFill>
                 <a:latin typeface="Calibri"/>
               </a:rPr>
@@ -8850,7 +8850,7 @@
             <a:r>
               <a:rPr sz="1750" b="0" i="0">
                 <a:solidFill>
-                  <a:srgbClr val="C5D2E4"/>
+                  <a:srgbClr val="CBD5E1"/>
                 </a:solidFill>
                 <a:latin typeface="Calibri"/>
               </a:rPr>
@@ -8874,7 +8874,7 @@
             <a:r>
               <a:rPr sz="1750" b="1" i="0">
                 <a:solidFill>
-                  <a:srgbClr val="F2F6FB"/>
+                  <a:srgbClr val="F8FAFC"/>
                 </a:solidFill>
                 <a:latin typeface="Calibri"/>
               </a:rPr>
@@ -8883,7 +8883,7 @@
             <a:r>
               <a:rPr sz="1750" b="0" i="0">
                 <a:solidFill>
-                  <a:srgbClr val="C5D2E4"/>
+                  <a:srgbClr val="CBD5E1"/>
                 </a:solidFill>
                 <a:latin typeface="Calibri"/>
               </a:rPr>
@@ -8940,7 +8940,7 @@
     <p:bg>
       <p:bgPr>
         <a:solidFill>
-          <a:srgbClr val="0B1220"/>
+          <a:srgbClr val="1E293B"/>
         </a:solidFill>
         <a:effectLst/>
       </p:bgPr>
@@ -8978,7 +8978,7 @@
             <a:r>
               <a:rPr sz="1100" b="0" i="0">
                 <a:solidFill>
-                  <a:srgbClr val="55688A"/>
+                  <a:srgbClr val="8296B0"/>
                 </a:solidFill>
                 <a:latin typeface="Calibri"/>
               </a:rPr>
@@ -9012,7 +9012,7 @@
             <a:r>
               <a:rPr sz="3600" b="1" i="0">
                 <a:solidFill>
-                  <a:srgbClr val="F2F6FB"/>
+                  <a:srgbClr val="F8FAFC"/>
                 </a:solidFill>
                 <a:latin typeface="Calibri Light"/>
               </a:rPr>
@@ -9095,7 +9095,7 @@
             <a:r>
               <a:rPr sz="1600" b="0" i="0">
                 <a:solidFill>
-                  <a:srgbClr val="C5D2E4"/>
+                  <a:srgbClr val="CBD5E1"/>
                 </a:solidFill>
                 <a:latin typeface="Calibri"/>
               </a:rPr>
@@ -9111,7 +9111,7 @@
             <a:r>
               <a:rPr sz="1400" b="0" i="0">
                 <a:solidFill>
-                  <a:srgbClr val="93A6C0"/>
+                  <a:srgbClr val="94A3B8"/>
                 </a:solidFill>
                 <a:latin typeface="Calibri"/>
               </a:rPr>
@@ -9146,7 +9146,7 @@
             <a:r>
               <a:rPr sz="1100" b="0" i="0">
                 <a:solidFill>
-                  <a:srgbClr val="55688A"/>
+                  <a:srgbClr val="8296B0"/>
                 </a:solidFill>
                 <a:latin typeface="Calibri"/>
               </a:rPr>
@@ -9169,7 +9169,7 @@
     <p:bg>
       <p:bgPr>
         <a:solidFill>
-          <a:srgbClr val="0B1220"/>
+          <a:srgbClr val="1E293B"/>
         </a:solidFill>
         <a:effectLst/>
       </p:bgPr>
@@ -9245,7 +9245,7 @@
             <a:r>
               <a:rPr sz="2900" b="1" i="0">
                 <a:solidFill>
-                  <a:srgbClr val="F2F6FB"/>
+                  <a:srgbClr val="F8FAFC"/>
                 </a:solidFill>
                 <a:latin typeface="Calibri Light"/>
               </a:rPr>
@@ -9324,7 +9324,7 @@
             <a:r>
               <a:rPr sz="1100" b="0" i="0">
                 <a:solidFill>
-                  <a:srgbClr val="55688A"/>
+                  <a:srgbClr val="8296B0"/>
                 </a:solidFill>
                 <a:latin typeface="Calibri"/>
               </a:rPr>
@@ -9375,7 +9375,7 @@
             <a:r>
               <a:rPr sz="1400" b="0" i="0">
                 <a:solidFill>
-                  <a:srgbClr val="C5D2E4"/>
+                  <a:srgbClr val="CBD5E1"/>
                 </a:solidFill>
                 <a:latin typeface="Calibri"/>
               </a:rPr>
@@ -9403,7 +9403,7 @@
             <a:r>
               <a:rPr sz="1400" b="0" i="0">
                 <a:solidFill>
-                  <a:srgbClr val="C5D2E4"/>
+                  <a:srgbClr val="CBD5E1"/>
                 </a:solidFill>
                 <a:latin typeface="Calibri"/>
               </a:rPr>
@@ -9431,7 +9431,7 @@
             <a:r>
               <a:rPr sz="1400" b="0" i="0">
                 <a:solidFill>
-                  <a:srgbClr val="C5D2E4"/>
+                  <a:srgbClr val="CBD5E1"/>
                 </a:solidFill>
                 <a:latin typeface="Calibri"/>
               </a:rPr>
@@ -9459,7 +9459,7 @@
             <a:r>
               <a:rPr sz="1400" b="0" i="0">
                 <a:solidFill>
-                  <a:srgbClr val="C5D2E4"/>
+                  <a:srgbClr val="CBD5E1"/>
                 </a:solidFill>
                 <a:latin typeface="Calibri"/>
               </a:rPr>
@@ -9487,7 +9487,7 @@
             <a:r>
               <a:rPr sz="1400" b="0" i="0">
                 <a:solidFill>
-                  <a:srgbClr val="C5D2E4"/>
+                  <a:srgbClr val="CBD5E1"/>
                 </a:solidFill>
                 <a:latin typeface="Calibri"/>
               </a:rPr>
@@ -9515,7 +9515,7 @@
             <a:r>
               <a:rPr sz="1400" b="0" i="0">
                 <a:solidFill>
-                  <a:srgbClr val="C5D2E4"/>
+                  <a:srgbClr val="CBD5E1"/>
                 </a:solidFill>
                 <a:latin typeface="Calibri"/>
               </a:rPr>
@@ -9543,7 +9543,7 @@
             <a:r>
               <a:rPr sz="1400" b="0" i="0">
                 <a:solidFill>
-                  <a:srgbClr val="C5D2E4"/>
+                  <a:srgbClr val="CBD5E1"/>
                 </a:solidFill>
                 <a:latin typeface="Calibri"/>
               </a:rPr>
@@ -9571,7 +9571,7 @@
             <a:r>
               <a:rPr sz="1400" b="0" i="0">
                 <a:solidFill>
-                  <a:srgbClr val="C5D2E4"/>
+                  <a:srgbClr val="CBD5E1"/>
                 </a:solidFill>
                 <a:latin typeface="Calibri"/>
               </a:rPr>
@@ -9594,7 +9594,7 @@
     <p:bg>
       <p:bgPr>
         <a:solidFill>
-          <a:srgbClr val="0B1220"/>
+          <a:srgbClr val="1E293B"/>
         </a:solidFill>
         <a:effectLst/>
       </p:bgPr>
@@ -9670,7 +9670,7 @@
             <a:r>
               <a:rPr sz="2900" b="1" i="0">
                 <a:solidFill>
-                  <a:srgbClr val="F2F6FB"/>
+                  <a:srgbClr val="F8FAFC"/>
                 </a:solidFill>
                 <a:latin typeface="Calibri Light"/>
               </a:rPr>
@@ -9749,7 +9749,7 @@
             <a:r>
               <a:rPr sz="1100" b="0" i="0">
                 <a:solidFill>
-                  <a:srgbClr val="55688A"/>
+                  <a:srgbClr val="8296B0"/>
                 </a:solidFill>
                 <a:latin typeface="Calibri"/>
               </a:rPr>
@@ -9838,7 +9838,7 @@
                   </a:txBody>
                   <a:tcPr anchor="ctr" marL="100584" marR="100584" marT="36576" marB="36576">
                     <a:solidFill>
-                      <a:srgbClr val="12303A"/>
+                      <a:srgbClr val="334155"/>
                     </a:solidFill>
                   </a:tcPr>
                 </a:tc>
@@ -9861,7 +9861,7 @@
                   </a:txBody>
                   <a:tcPr anchor="ctr" marL="100584" marR="100584" marT="36576" marB="36576">
                     <a:solidFill>
-                      <a:srgbClr val="12303A"/>
+                      <a:srgbClr val="334155"/>
                     </a:solidFill>
                   </a:tcPr>
                 </a:tc>
@@ -9884,7 +9884,7 @@
                   </a:txBody>
                   <a:tcPr anchor="ctr" marL="100584" marR="100584" marT="36576" marB="36576">
                     <a:solidFill>
-                      <a:srgbClr val="12303A"/>
+                      <a:srgbClr val="334155"/>
                     </a:solidFill>
                   </a:tcPr>
                 </a:tc>
@@ -9907,7 +9907,7 @@
                   </a:txBody>
                   <a:tcPr anchor="ctr" marL="100584" marR="100584" marT="36576" marB="36576">
                     <a:solidFill>
-                      <a:srgbClr val="12303A"/>
+                      <a:srgbClr val="334155"/>
                     </a:solidFill>
                   </a:tcPr>
                 </a:tc>
@@ -9930,7 +9930,7 @@
                   </a:txBody>
                   <a:tcPr anchor="ctr" marL="100584" marR="100584" marT="36576" marB="36576">
                     <a:solidFill>
-                      <a:srgbClr val="12303A"/>
+                      <a:srgbClr val="334155"/>
                     </a:solidFill>
                   </a:tcPr>
                 </a:tc>
@@ -9953,7 +9953,7 @@
                   </a:txBody>
                   <a:tcPr anchor="ctr" marL="100584" marR="100584" marT="36576" marB="36576">
                     <a:solidFill>
-                      <a:srgbClr val="12303A"/>
+                      <a:srgbClr val="334155"/>
                     </a:solidFill>
                   </a:tcPr>
                 </a:tc>
@@ -9968,7 +9968,7 @@
                       <a:r>
                         <a:rPr sz="1350" b="0" i="0">
                           <a:solidFill>
-                            <a:srgbClr val="C5D2E4"/>
+                            <a:srgbClr val="CBD5E1"/>
                           </a:solidFill>
                           <a:latin typeface="Calibri"/>
                         </a:rPr>
@@ -9978,7 +9978,7 @@
                   </a:txBody>
                   <a:tcPr anchor="ctr" marL="100584" marR="100584" marT="36576" marB="36576">
                     <a:solidFill>
-                      <a:srgbClr val="0E1929"/>
+                      <a:srgbClr val="243247"/>
                     </a:solidFill>
                   </a:tcPr>
                 </a:tc>
@@ -9991,7 +9991,7 @@
                       <a:r>
                         <a:rPr sz="1350" b="0" i="0">
                           <a:solidFill>
-                            <a:srgbClr val="C5D2E4"/>
+                            <a:srgbClr val="CBD5E1"/>
                           </a:solidFill>
                           <a:latin typeface="Calibri"/>
                         </a:rPr>
@@ -10001,7 +10001,7 @@
                   </a:txBody>
                   <a:tcPr anchor="ctr" marL="100584" marR="100584" marT="36576" marB="36576">
                     <a:solidFill>
-                      <a:srgbClr val="0E1929"/>
+                      <a:srgbClr val="243247"/>
                     </a:solidFill>
                   </a:tcPr>
                 </a:tc>
@@ -10014,7 +10014,7 @@
                       <a:r>
                         <a:rPr sz="1350" b="0" i="0">
                           <a:solidFill>
-                            <a:srgbClr val="C5D2E4"/>
+                            <a:srgbClr val="CBD5E1"/>
                           </a:solidFill>
                           <a:latin typeface="Calibri"/>
                         </a:rPr>
@@ -10024,7 +10024,7 @@
                   </a:txBody>
                   <a:tcPr anchor="ctr" marL="100584" marR="100584" marT="36576" marB="36576">
                     <a:solidFill>
-                      <a:srgbClr val="0E1929"/>
+                      <a:srgbClr val="243247"/>
                     </a:solidFill>
                   </a:tcPr>
                 </a:tc>
@@ -10037,7 +10037,7 @@
                       <a:r>
                         <a:rPr sz="1350" b="0" i="0">
                           <a:solidFill>
-                            <a:srgbClr val="C5D2E4"/>
+                            <a:srgbClr val="CBD5E1"/>
                           </a:solidFill>
                           <a:latin typeface="Calibri"/>
                         </a:rPr>
@@ -10047,7 +10047,7 @@
                   </a:txBody>
                   <a:tcPr anchor="ctr" marL="100584" marR="100584" marT="36576" marB="36576">
                     <a:solidFill>
-                      <a:srgbClr val="0E1929"/>
+                      <a:srgbClr val="243247"/>
                     </a:solidFill>
                   </a:tcPr>
                 </a:tc>
@@ -10060,7 +10060,7 @@
                       <a:r>
                         <a:rPr sz="1350" b="0" i="0">
                           <a:solidFill>
-                            <a:srgbClr val="C5D2E4"/>
+                            <a:srgbClr val="CBD5E1"/>
                           </a:solidFill>
                           <a:latin typeface="Calibri"/>
                         </a:rPr>
@@ -10070,7 +10070,7 @@
                   </a:txBody>
                   <a:tcPr anchor="ctr" marL="100584" marR="100584" marT="36576" marB="36576">
                     <a:solidFill>
-                      <a:srgbClr val="0E1929"/>
+                      <a:srgbClr val="243247"/>
                     </a:solidFill>
                   </a:tcPr>
                 </a:tc>
@@ -10083,7 +10083,7 @@
                       <a:r>
                         <a:rPr sz="1350" b="0" i="0">
                           <a:solidFill>
-                            <a:srgbClr val="C5D2E4"/>
+                            <a:srgbClr val="CBD5E1"/>
                           </a:solidFill>
                           <a:latin typeface="Calibri"/>
                         </a:rPr>
@@ -10093,7 +10093,7 @@
                   </a:txBody>
                   <a:tcPr anchor="ctr" marL="100584" marR="100584" marT="36576" marB="36576">
                     <a:solidFill>
-                      <a:srgbClr val="0E1929"/>
+                      <a:srgbClr val="243247"/>
                     </a:solidFill>
                   </a:tcPr>
                 </a:tc>
@@ -10108,7 +10108,7 @@
                       <a:r>
                         <a:rPr sz="1350" b="0" i="0">
                           <a:solidFill>
-                            <a:srgbClr val="C5D2E4"/>
+                            <a:srgbClr val="CBD5E1"/>
                           </a:solidFill>
                           <a:latin typeface="Calibri"/>
                         </a:rPr>
@@ -10118,7 +10118,7 @@
                   </a:txBody>
                   <a:tcPr anchor="ctr" marL="100584" marR="100584" marT="36576" marB="36576">
                     <a:solidFill>
-                      <a:srgbClr val="121E30"/>
+                      <a:srgbClr val="2B3A50"/>
                     </a:solidFill>
                   </a:tcPr>
                 </a:tc>
@@ -10131,7 +10131,7 @@
                       <a:r>
                         <a:rPr sz="1350" b="0" i="0">
                           <a:solidFill>
-                            <a:srgbClr val="C5D2E4"/>
+                            <a:srgbClr val="CBD5E1"/>
                           </a:solidFill>
                           <a:latin typeface="Calibri"/>
                         </a:rPr>
@@ -10141,7 +10141,7 @@
                   </a:txBody>
                   <a:tcPr anchor="ctr" marL="100584" marR="100584" marT="36576" marB="36576">
                     <a:solidFill>
-                      <a:srgbClr val="121E30"/>
+                      <a:srgbClr val="2B3A50"/>
                     </a:solidFill>
                   </a:tcPr>
                 </a:tc>
@@ -10154,7 +10154,7 @@
                       <a:r>
                         <a:rPr sz="1350" b="0" i="0">
                           <a:solidFill>
-                            <a:srgbClr val="C5D2E4"/>
+                            <a:srgbClr val="CBD5E1"/>
                           </a:solidFill>
                           <a:latin typeface="Calibri"/>
                         </a:rPr>
@@ -10164,7 +10164,7 @@
                   </a:txBody>
                   <a:tcPr anchor="ctr" marL="100584" marR="100584" marT="36576" marB="36576">
                     <a:solidFill>
-                      <a:srgbClr val="121E30"/>
+                      <a:srgbClr val="2B3A50"/>
                     </a:solidFill>
                   </a:tcPr>
                 </a:tc>
@@ -10177,7 +10177,7 @@
                       <a:r>
                         <a:rPr sz="1350" b="0" i="0">
                           <a:solidFill>
-                            <a:srgbClr val="C5D2E4"/>
+                            <a:srgbClr val="CBD5E1"/>
                           </a:solidFill>
                           <a:latin typeface="Calibri"/>
                         </a:rPr>
@@ -10187,7 +10187,7 @@
                   </a:txBody>
                   <a:tcPr anchor="ctr" marL="100584" marR="100584" marT="36576" marB="36576">
                     <a:solidFill>
-                      <a:srgbClr val="121E30"/>
+                      <a:srgbClr val="2B3A50"/>
                     </a:solidFill>
                   </a:tcPr>
                 </a:tc>
@@ -10200,7 +10200,7 @@
                       <a:r>
                         <a:rPr sz="1350" b="0" i="0">
                           <a:solidFill>
-                            <a:srgbClr val="C5D2E4"/>
+                            <a:srgbClr val="CBD5E1"/>
                           </a:solidFill>
                           <a:latin typeface="Calibri"/>
                         </a:rPr>
@@ -10210,7 +10210,7 @@
                   </a:txBody>
                   <a:tcPr anchor="ctr" marL="100584" marR="100584" marT="36576" marB="36576">
                     <a:solidFill>
-                      <a:srgbClr val="121E30"/>
+                      <a:srgbClr val="2B3A50"/>
                     </a:solidFill>
                   </a:tcPr>
                 </a:tc>
@@ -10223,7 +10223,7 @@
                       <a:r>
                         <a:rPr sz="1350" b="0" i="0">
                           <a:solidFill>
-                            <a:srgbClr val="C5D2E4"/>
+                            <a:srgbClr val="CBD5E1"/>
                           </a:solidFill>
                           <a:latin typeface="Calibri"/>
                         </a:rPr>
@@ -10233,7 +10233,7 @@
                   </a:txBody>
                   <a:tcPr anchor="ctr" marL="100584" marR="100584" marT="36576" marB="36576">
                     <a:solidFill>
-                      <a:srgbClr val="121E30"/>
+                      <a:srgbClr val="2B3A50"/>
                     </a:solidFill>
                   </a:tcPr>
                 </a:tc>
@@ -10248,7 +10248,7 @@
                       <a:r>
                         <a:rPr sz="1350" b="0" i="0">
                           <a:solidFill>
-                            <a:srgbClr val="C5D2E4"/>
+                            <a:srgbClr val="CBD5E1"/>
                           </a:solidFill>
                           <a:latin typeface="Calibri"/>
                         </a:rPr>
@@ -10258,7 +10258,7 @@
                   </a:txBody>
                   <a:tcPr anchor="ctr" marL="100584" marR="100584" marT="36576" marB="36576">
                     <a:solidFill>
-                      <a:srgbClr val="0E1929"/>
+                      <a:srgbClr val="243247"/>
                     </a:solidFill>
                   </a:tcPr>
                 </a:tc>
@@ -10271,7 +10271,7 @@
                       <a:r>
                         <a:rPr sz="1350" b="0" i="0">
                           <a:solidFill>
-                            <a:srgbClr val="C5D2E4"/>
+                            <a:srgbClr val="CBD5E1"/>
                           </a:solidFill>
                           <a:latin typeface="Calibri"/>
                         </a:rPr>
@@ -10281,7 +10281,7 @@
                   </a:txBody>
                   <a:tcPr anchor="ctr" marL="100584" marR="100584" marT="36576" marB="36576">
                     <a:solidFill>
-                      <a:srgbClr val="0E1929"/>
+                      <a:srgbClr val="243247"/>
                     </a:solidFill>
                   </a:tcPr>
                 </a:tc>
@@ -10294,7 +10294,7 @@
                       <a:r>
                         <a:rPr sz="1350" b="0" i="0">
                           <a:solidFill>
-                            <a:srgbClr val="C5D2E4"/>
+                            <a:srgbClr val="CBD5E1"/>
                           </a:solidFill>
                           <a:latin typeface="Calibri"/>
                         </a:rPr>
@@ -10304,7 +10304,7 @@
                   </a:txBody>
                   <a:tcPr anchor="ctr" marL="100584" marR="100584" marT="36576" marB="36576">
                     <a:solidFill>
-                      <a:srgbClr val="0E1929"/>
+                      <a:srgbClr val="243247"/>
                     </a:solidFill>
                   </a:tcPr>
                 </a:tc>
@@ -10317,7 +10317,7 @@
                       <a:r>
                         <a:rPr sz="1350" b="0" i="0">
                           <a:solidFill>
-                            <a:srgbClr val="C5D2E4"/>
+                            <a:srgbClr val="CBD5E1"/>
                           </a:solidFill>
                           <a:latin typeface="Calibri"/>
                         </a:rPr>
@@ -10327,7 +10327,7 @@
                   </a:txBody>
                   <a:tcPr anchor="ctr" marL="100584" marR="100584" marT="36576" marB="36576">
                     <a:solidFill>
-                      <a:srgbClr val="0E1929"/>
+                      <a:srgbClr val="243247"/>
                     </a:solidFill>
                   </a:tcPr>
                 </a:tc>
@@ -10340,7 +10340,7 @@
                       <a:r>
                         <a:rPr sz="1350" b="0" i="0">
                           <a:solidFill>
-                            <a:srgbClr val="C5D2E4"/>
+                            <a:srgbClr val="CBD5E1"/>
                           </a:solidFill>
                           <a:latin typeface="Calibri"/>
                         </a:rPr>
@@ -10350,7 +10350,7 @@
                   </a:txBody>
                   <a:tcPr anchor="ctr" marL="100584" marR="100584" marT="36576" marB="36576">
                     <a:solidFill>
-                      <a:srgbClr val="0E1929"/>
+                      <a:srgbClr val="243247"/>
                     </a:solidFill>
                   </a:tcPr>
                 </a:tc>
@@ -10363,7 +10363,7 @@
                       <a:r>
                         <a:rPr sz="1350" b="0" i="0">
                           <a:solidFill>
-                            <a:srgbClr val="C5D2E4"/>
+                            <a:srgbClr val="CBD5E1"/>
                           </a:solidFill>
                           <a:latin typeface="Calibri"/>
                         </a:rPr>
@@ -10373,7 +10373,7 @@
                   </a:txBody>
                   <a:tcPr anchor="ctr" marL="100584" marR="100584" marT="36576" marB="36576">
                     <a:solidFill>
-                      <a:srgbClr val="0E1929"/>
+                      <a:srgbClr val="243247"/>
                     </a:solidFill>
                   </a:tcPr>
                 </a:tc>
@@ -10388,7 +10388,7 @@
                       <a:r>
                         <a:rPr sz="1350" b="1" i="0">
                           <a:solidFill>
-                            <a:srgbClr val="F2F6FB"/>
+                            <a:srgbClr val="F8FAFC"/>
                           </a:solidFill>
                           <a:latin typeface="Calibri"/>
                         </a:rPr>
@@ -10398,7 +10398,7 @@
                   </a:txBody>
                   <a:tcPr anchor="ctr" marL="100584" marR="100584" marT="36576" marB="36576">
                     <a:solidFill>
-                      <a:srgbClr val="12303A"/>
+                      <a:srgbClr val="334155"/>
                     </a:solidFill>
                   </a:tcPr>
                 </a:tc>
@@ -10411,7 +10411,7 @@
                       <a:r>
                         <a:rPr sz="1350" b="1" i="0">
                           <a:solidFill>
-                            <a:srgbClr val="F2F6FB"/>
+                            <a:srgbClr val="F8FAFC"/>
                           </a:solidFill>
                           <a:latin typeface="Calibri"/>
                         </a:rPr>
@@ -10421,7 +10421,7 @@
                   </a:txBody>
                   <a:tcPr anchor="ctr" marL="100584" marR="100584" marT="36576" marB="36576">
                     <a:solidFill>
-                      <a:srgbClr val="12303A"/>
+                      <a:srgbClr val="334155"/>
                     </a:solidFill>
                   </a:tcPr>
                 </a:tc>
@@ -10434,7 +10434,7 @@
                       <a:r>
                         <a:rPr sz="1350" b="1" i="0">
                           <a:solidFill>
-                            <a:srgbClr val="F2F6FB"/>
+                            <a:srgbClr val="F8FAFC"/>
                           </a:solidFill>
                           <a:latin typeface="Calibri"/>
                         </a:rPr>
@@ -10444,7 +10444,7 @@
                   </a:txBody>
                   <a:tcPr anchor="ctr" marL="100584" marR="100584" marT="36576" marB="36576">
                     <a:solidFill>
-                      <a:srgbClr val="12303A"/>
+                      <a:srgbClr val="334155"/>
                     </a:solidFill>
                   </a:tcPr>
                 </a:tc>
@@ -10457,7 +10457,7 @@
                       <a:r>
                         <a:rPr sz="1350" b="1" i="0">
                           <a:solidFill>
-                            <a:srgbClr val="F2F6FB"/>
+                            <a:srgbClr val="F8FAFC"/>
                           </a:solidFill>
                           <a:latin typeface="Calibri"/>
                         </a:rPr>
@@ -10467,7 +10467,7 @@
                   </a:txBody>
                   <a:tcPr anchor="ctr" marL="100584" marR="100584" marT="36576" marB="36576">
                     <a:solidFill>
-                      <a:srgbClr val="12303A"/>
+                      <a:srgbClr val="334155"/>
                     </a:solidFill>
                   </a:tcPr>
                 </a:tc>
@@ -10480,7 +10480,7 @@
                       <a:r>
                         <a:rPr sz="1350" b="1" i="0">
                           <a:solidFill>
-                            <a:srgbClr val="F2F6FB"/>
+                            <a:srgbClr val="F8FAFC"/>
                           </a:solidFill>
                           <a:latin typeface="Calibri"/>
                         </a:rPr>
@@ -10490,7 +10490,7 @@
                   </a:txBody>
                   <a:tcPr anchor="ctr" marL="100584" marR="100584" marT="36576" marB="36576">
                     <a:solidFill>
-                      <a:srgbClr val="12303A"/>
+                      <a:srgbClr val="334155"/>
                     </a:solidFill>
                   </a:tcPr>
                 </a:tc>
@@ -10503,7 +10503,7 @@
                       <a:r>
                         <a:rPr sz="1350" b="1" i="0">
                           <a:solidFill>
-                            <a:srgbClr val="F2F6FB"/>
+                            <a:srgbClr val="F8FAFC"/>
                           </a:solidFill>
                           <a:latin typeface="Calibri"/>
                         </a:rPr>
@@ -10513,7 +10513,7 @@
                   </a:txBody>
                   <a:tcPr anchor="ctr" marL="100584" marR="100584" marT="36576" marB="36576">
                     <a:solidFill>
-                      <a:srgbClr val="12303A"/>
+                      <a:srgbClr val="334155"/>
                     </a:solidFill>
                   </a:tcPr>
                 </a:tc>
@@ -10560,7 +10560,7 @@
             <a:r>
               <a:rPr sz="1500" b="0" i="0">
                 <a:solidFill>
-                  <a:srgbClr val="C5D2E4"/>
+                  <a:srgbClr val="CBD5E1"/>
                 </a:solidFill>
                 <a:latin typeface="Calibri"/>
               </a:rPr>
@@ -10584,7 +10584,7 @@
             <a:r>
               <a:rPr sz="1500" b="0" i="0">
                 <a:solidFill>
-                  <a:srgbClr val="C5D2E4"/>
+                  <a:srgbClr val="CBD5E1"/>
                 </a:solidFill>
                 <a:latin typeface="Calibri"/>
               </a:rPr>
@@ -10608,7 +10608,7 @@
             <a:r>
               <a:rPr sz="1500" b="0" i="0">
                 <a:solidFill>
-                  <a:srgbClr val="C5D2E4"/>
+                  <a:srgbClr val="CBD5E1"/>
                 </a:solidFill>
                 <a:latin typeface="Calibri"/>
               </a:rPr>
@@ -10631,7 +10631,7 @@
     <p:bg>
       <p:bgPr>
         <a:solidFill>
-          <a:srgbClr val="0B1220"/>
+          <a:srgbClr val="1E293B"/>
         </a:solidFill>
         <a:effectLst/>
       </p:bgPr>
@@ -10707,7 +10707,7 @@
             <a:r>
               <a:rPr sz="2800" b="1" i="0">
                 <a:solidFill>
-                  <a:srgbClr val="F2F6FB"/>
+                  <a:srgbClr val="F8FAFC"/>
                 </a:solidFill>
                 <a:latin typeface="Calibri Light"/>
               </a:rPr>
@@ -10786,7 +10786,7 @@
             <a:r>
               <a:rPr sz="1100" b="0" i="0">
                 <a:solidFill>
-                  <a:srgbClr val="55688A"/>
+                  <a:srgbClr val="8296B0"/>
                 </a:solidFill>
                 <a:latin typeface="Calibri"/>
               </a:rPr>
@@ -10833,7 +10833,7 @@
             <a:r>
               <a:rPr sz="1650" b="0" i="0">
                 <a:solidFill>
-                  <a:srgbClr val="C5D2E4"/>
+                  <a:srgbClr val="CBD5E1"/>
                 </a:solidFill>
                 <a:latin typeface="Calibri"/>
               </a:rPr>
@@ -10851,7 +10851,7 @@
             <a:r>
               <a:rPr sz="1650" b="0" i="0">
                 <a:solidFill>
-                  <a:srgbClr val="C5D2E4"/>
+                  <a:srgbClr val="CBD5E1"/>
                 </a:solidFill>
                 <a:latin typeface="Calibri"/>
               </a:rPr>
@@ -10869,7 +10869,7 @@
             <a:r>
               <a:rPr sz="1650" b="0" i="0">
                 <a:solidFill>
-                  <a:srgbClr val="C5D2E4"/>
+                  <a:srgbClr val="CBD5E1"/>
                 </a:solidFill>
                 <a:latin typeface="Calibri"/>
               </a:rPr>
@@ -10887,7 +10887,7 @@
             <a:r>
               <a:rPr sz="1650" b="0" i="0">
                 <a:solidFill>
-                  <a:srgbClr val="C5D2E4"/>
+                  <a:srgbClr val="CBD5E1"/>
                 </a:solidFill>
                 <a:latin typeface="Calibri"/>
               </a:rPr>
@@ -10920,7 +10920,7 @@
             <a:r>
               <a:rPr sz="1650" b="0" i="0">
                 <a:solidFill>
-                  <a:srgbClr val="C5D2E4"/>
+                  <a:srgbClr val="CBD5E1"/>
                 </a:solidFill>
                 <a:latin typeface="Calibri"/>
               </a:rPr>
@@ -10944,7 +10944,7 @@
             <a:r>
               <a:rPr sz="1650" b="0" i="0">
                 <a:solidFill>
-                  <a:srgbClr val="C5D2E4"/>
+                  <a:srgbClr val="CBD5E1"/>
                 </a:solidFill>
                 <a:latin typeface="Calibri"/>
               </a:rPr>
@@ -10968,7 +10968,7 @@
             <a:r>
               <a:rPr sz="1650" b="0" i="0">
                 <a:solidFill>
-                  <a:srgbClr val="C5D2E4"/>
+                  <a:srgbClr val="CBD5E1"/>
                 </a:solidFill>
                 <a:latin typeface="Calibri"/>
               </a:rPr>
@@ -10991,7 +10991,7 @@
     <p:bg>
       <p:bgPr>
         <a:solidFill>
-          <a:srgbClr val="0B1220"/>
+          <a:srgbClr val="1E293B"/>
         </a:solidFill>
         <a:effectLst/>
       </p:bgPr>
@@ -11067,7 +11067,7 @@
             <a:r>
               <a:rPr sz="2900" b="1" i="0">
                 <a:solidFill>
-                  <a:srgbClr val="F2F6FB"/>
+                  <a:srgbClr val="F8FAFC"/>
                 </a:solidFill>
                 <a:latin typeface="Calibri Light"/>
               </a:rPr>
@@ -11146,7 +11146,7 @@
             <a:r>
               <a:rPr sz="1100" b="0" i="0">
                 <a:solidFill>
-                  <a:srgbClr val="55688A"/>
+                  <a:srgbClr val="8296B0"/>
                 </a:solidFill>
                 <a:latin typeface="Calibri"/>
               </a:rPr>
@@ -11193,7 +11193,7 @@
             <a:r>
               <a:rPr sz="1800" b="1" i="0">
                 <a:solidFill>
-                  <a:srgbClr val="F2F6FB"/>
+                  <a:srgbClr val="F8FAFC"/>
                 </a:solidFill>
                 <a:latin typeface="Calibri"/>
               </a:rPr>
@@ -11202,7 +11202,7 @@
             <a:r>
               <a:rPr sz="1800" b="0" i="0">
                 <a:solidFill>
-                  <a:srgbClr val="C5D2E4"/>
+                  <a:srgbClr val="CBD5E1"/>
                 </a:solidFill>
                 <a:latin typeface="Calibri"/>
               </a:rPr>
@@ -11226,7 +11226,7 @@
             <a:r>
               <a:rPr sz="1800" b="1" i="0">
                 <a:solidFill>
-                  <a:srgbClr val="F2F6FB"/>
+                  <a:srgbClr val="F8FAFC"/>
                 </a:solidFill>
                 <a:latin typeface="Calibri"/>
               </a:rPr>
@@ -11235,7 +11235,7 @@
             <a:r>
               <a:rPr sz="1800" b="0" i="0">
                 <a:solidFill>
-                  <a:srgbClr val="C5D2E4"/>
+                  <a:srgbClr val="CBD5E1"/>
                 </a:solidFill>
                 <a:latin typeface="Calibri"/>
               </a:rPr>
@@ -11259,7 +11259,7 @@
             <a:r>
               <a:rPr sz="1800" b="1" i="0">
                 <a:solidFill>
-                  <a:srgbClr val="F2F6FB"/>
+                  <a:srgbClr val="F8FAFC"/>
                 </a:solidFill>
                 <a:latin typeface="Calibri"/>
               </a:rPr>
@@ -11268,7 +11268,7 @@
             <a:r>
               <a:rPr sz="1800" b="0" i="0">
                 <a:solidFill>
-                  <a:srgbClr val="C5D2E4"/>
+                  <a:srgbClr val="CBD5E1"/>
                 </a:solidFill>
                 <a:latin typeface="Calibri"/>
               </a:rPr>
@@ -11292,7 +11292,7 @@
             <a:r>
               <a:rPr sz="1800" b="1" i="0">
                 <a:solidFill>
-                  <a:srgbClr val="F2F6FB"/>
+                  <a:srgbClr val="F8FAFC"/>
                 </a:solidFill>
                 <a:latin typeface="Calibri"/>
               </a:rPr>
@@ -11301,7 +11301,7 @@
             <a:r>
               <a:rPr sz="1800" b="0" i="0">
                 <a:solidFill>
-                  <a:srgbClr val="C5D2E4"/>
+                  <a:srgbClr val="CBD5E1"/>
                 </a:solidFill>
                 <a:latin typeface="Calibri"/>
               </a:rPr>
@@ -11325,7 +11325,7 @@
             <a:r>
               <a:rPr sz="1800" b="0" i="0">
                 <a:solidFill>
-                  <a:srgbClr val="C5D2E4"/>
+                  <a:srgbClr val="CBD5E1"/>
                 </a:solidFill>
                 <a:latin typeface="Calibri"/>
               </a:rPr>
@@ -11348,7 +11348,7 @@
     <p:bg>
       <p:bgPr>
         <a:solidFill>
-          <a:srgbClr val="0B1220"/>
+          <a:srgbClr val="1E293B"/>
         </a:solidFill>
         <a:effectLst/>
       </p:bgPr>
@@ -11410,7 +11410,7 @@
             <a:r>
               <a:rPr sz="1100" b="0" i="0">
                 <a:solidFill>
-                  <a:srgbClr val="55688A"/>
+                  <a:srgbClr val="8296B0"/>
                 </a:solidFill>
                 <a:latin typeface="Calibri"/>
               </a:rPr>
@@ -11433,7 +11433,7 @@
     <p:bg>
       <p:bgPr>
         <a:solidFill>
-          <a:srgbClr val="0B1220"/>
+          <a:srgbClr val="1E293B"/>
         </a:solidFill>
         <a:effectLst/>
       </p:bgPr>
@@ -11509,7 +11509,7 @@
             <a:r>
               <a:rPr sz="2900" b="1" i="0">
                 <a:solidFill>
-                  <a:srgbClr val="F2F6FB"/>
+                  <a:srgbClr val="F8FAFC"/>
                 </a:solidFill>
                 <a:latin typeface="Calibri Light"/>
               </a:rPr>
@@ -11588,7 +11588,7 @@
             <a:r>
               <a:rPr sz="1100" b="0" i="0">
                 <a:solidFill>
-                  <a:srgbClr val="55688A"/>
+                  <a:srgbClr val="8296B0"/>
                 </a:solidFill>
                 <a:latin typeface="Calibri"/>
               </a:rPr>
@@ -11640,7 +11640,7 @@
                   </a:txBody>
                   <a:tcPr anchor="ctr" marL="100584" marR="100584" marT="36576" marB="36576">
                     <a:solidFill>
-                      <a:srgbClr val="12303A"/>
+                      <a:srgbClr val="334155"/>
                     </a:solidFill>
                   </a:tcPr>
                 </a:tc>
@@ -11663,7 +11663,7 @@
                   </a:txBody>
                   <a:tcPr anchor="ctr" marL="100584" marR="100584" marT="36576" marB="36576">
                     <a:solidFill>
-                      <a:srgbClr val="12303A"/>
+                      <a:srgbClr val="334155"/>
                     </a:solidFill>
                   </a:tcPr>
                 </a:tc>
@@ -11686,7 +11686,7 @@
                   </a:txBody>
                   <a:tcPr anchor="ctr" marL="100584" marR="100584" marT="36576" marB="36576">
                     <a:solidFill>
-                      <a:srgbClr val="12303A"/>
+                      <a:srgbClr val="334155"/>
                     </a:solidFill>
                   </a:tcPr>
                 </a:tc>
@@ -11701,7 +11701,7 @@
                       <a:r>
                         <a:rPr sz="1500" b="0" i="0">
                           <a:solidFill>
-                            <a:srgbClr val="C5D2E4"/>
+                            <a:srgbClr val="CBD5E1"/>
                           </a:solidFill>
                           <a:latin typeface="Calibri"/>
                         </a:rPr>
@@ -11711,7 +11711,7 @@
                   </a:txBody>
                   <a:tcPr anchor="ctr" marL="100584" marR="100584" marT="36576" marB="36576">
                     <a:solidFill>
-                      <a:srgbClr val="0E1929"/>
+                      <a:srgbClr val="243247"/>
                     </a:solidFill>
                   </a:tcPr>
                 </a:tc>
@@ -11724,7 +11724,7 @@
                       <a:r>
                         <a:rPr sz="1500" b="0" i="0">
                           <a:solidFill>
-                            <a:srgbClr val="C5D2E4"/>
+                            <a:srgbClr val="CBD5E1"/>
                           </a:solidFill>
                           <a:latin typeface="Calibri"/>
                         </a:rPr>
@@ -11734,7 +11734,7 @@
                   </a:txBody>
                   <a:tcPr anchor="ctr" marL="100584" marR="100584" marT="36576" marB="36576">
                     <a:solidFill>
-                      <a:srgbClr val="0E1929"/>
+                      <a:srgbClr val="243247"/>
                     </a:solidFill>
                   </a:tcPr>
                 </a:tc>
@@ -11747,7 +11747,7 @@
                       <a:r>
                         <a:rPr sz="1500" b="0" i="0">
                           <a:solidFill>
-                            <a:srgbClr val="C5D2E4"/>
+                            <a:srgbClr val="CBD5E1"/>
                           </a:solidFill>
                           <a:latin typeface="Calibri"/>
                         </a:rPr>
@@ -11757,7 +11757,7 @@
                   </a:txBody>
                   <a:tcPr anchor="ctr" marL="100584" marR="100584" marT="36576" marB="36576">
                     <a:solidFill>
-                      <a:srgbClr val="0E1929"/>
+                      <a:srgbClr val="243247"/>
                     </a:solidFill>
                   </a:tcPr>
                 </a:tc>
@@ -11772,7 +11772,7 @@
                       <a:r>
                         <a:rPr sz="1500" b="0" i="0">
                           <a:solidFill>
-                            <a:srgbClr val="C5D2E4"/>
+                            <a:srgbClr val="CBD5E1"/>
                           </a:solidFill>
                           <a:latin typeface="Calibri"/>
                         </a:rPr>
@@ -11782,7 +11782,7 @@
                   </a:txBody>
                   <a:tcPr anchor="ctr" marL="100584" marR="100584" marT="36576" marB="36576">
                     <a:solidFill>
-                      <a:srgbClr val="121E30"/>
+                      <a:srgbClr val="2B3A50"/>
                     </a:solidFill>
                   </a:tcPr>
                 </a:tc>
@@ -11795,7 +11795,7 @@
                       <a:r>
                         <a:rPr sz="1500" b="0" i="0">
                           <a:solidFill>
-                            <a:srgbClr val="C5D2E4"/>
+                            <a:srgbClr val="CBD5E1"/>
                           </a:solidFill>
                           <a:latin typeface="Calibri"/>
                         </a:rPr>
@@ -11805,7 +11805,7 @@
                   </a:txBody>
                   <a:tcPr anchor="ctr" marL="100584" marR="100584" marT="36576" marB="36576">
                     <a:solidFill>
-                      <a:srgbClr val="121E30"/>
+                      <a:srgbClr val="2B3A50"/>
                     </a:solidFill>
                   </a:tcPr>
                 </a:tc>
@@ -11818,7 +11818,7 @@
                       <a:r>
                         <a:rPr sz="1500" b="0" i="0">
                           <a:solidFill>
-                            <a:srgbClr val="C5D2E4"/>
+                            <a:srgbClr val="CBD5E1"/>
                           </a:solidFill>
                           <a:latin typeface="Calibri"/>
                         </a:rPr>
@@ -11828,7 +11828,7 @@
                   </a:txBody>
                   <a:tcPr anchor="ctr" marL="100584" marR="100584" marT="36576" marB="36576">
                     <a:solidFill>
-                      <a:srgbClr val="121E30"/>
+                      <a:srgbClr val="2B3A50"/>
                     </a:solidFill>
                   </a:tcPr>
                 </a:tc>
@@ -11843,7 +11843,7 @@
                       <a:r>
                         <a:rPr sz="1500" b="0" i="0">
                           <a:solidFill>
-                            <a:srgbClr val="C5D2E4"/>
+                            <a:srgbClr val="CBD5E1"/>
                           </a:solidFill>
                           <a:latin typeface="Calibri"/>
                         </a:rPr>
@@ -11853,7 +11853,7 @@
                   </a:txBody>
                   <a:tcPr anchor="ctr" marL="100584" marR="100584" marT="36576" marB="36576">
                     <a:solidFill>
-                      <a:srgbClr val="0E1929"/>
+                      <a:srgbClr val="243247"/>
                     </a:solidFill>
                   </a:tcPr>
                 </a:tc>
@@ -11866,7 +11866,7 @@
                       <a:r>
                         <a:rPr sz="1500" b="0" i="0">
                           <a:solidFill>
-                            <a:srgbClr val="C5D2E4"/>
+                            <a:srgbClr val="CBD5E1"/>
                           </a:solidFill>
                           <a:latin typeface="Calibri"/>
                         </a:rPr>
@@ -11876,7 +11876,7 @@
                   </a:txBody>
                   <a:tcPr anchor="ctr" marL="100584" marR="100584" marT="36576" marB="36576">
                     <a:solidFill>
-                      <a:srgbClr val="0E1929"/>
+                      <a:srgbClr val="243247"/>
                     </a:solidFill>
                   </a:tcPr>
                 </a:tc>
@@ -11889,7 +11889,7 @@
                       <a:r>
                         <a:rPr sz="1500" b="0" i="0">
                           <a:solidFill>
-                            <a:srgbClr val="C5D2E4"/>
+                            <a:srgbClr val="CBD5E1"/>
                           </a:solidFill>
                           <a:latin typeface="Calibri"/>
                         </a:rPr>
@@ -11899,7 +11899,7 @@
                   </a:txBody>
                   <a:tcPr anchor="ctr" marL="100584" marR="100584" marT="36576" marB="36576">
                     <a:solidFill>
-                      <a:srgbClr val="0E1929"/>
+                      <a:srgbClr val="243247"/>
                     </a:solidFill>
                   </a:tcPr>
                 </a:tc>
@@ -11914,7 +11914,7 @@
                       <a:r>
                         <a:rPr sz="1500" b="0" i="0">
                           <a:solidFill>
-                            <a:srgbClr val="C5D2E4"/>
+                            <a:srgbClr val="CBD5E1"/>
                           </a:solidFill>
                           <a:latin typeface="Calibri"/>
                         </a:rPr>
@@ -11924,7 +11924,7 @@
                   </a:txBody>
                   <a:tcPr anchor="ctr" marL="100584" marR="100584" marT="36576" marB="36576">
                     <a:solidFill>
-                      <a:srgbClr val="121E30"/>
+                      <a:srgbClr val="2B3A50"/>
                     </a:solidFill>
                   </a:tcPr>
                 </a:tc>
@@ -11937,7 +11937,7 @@
                       <a:r>
                         <a:rPr sz="1500" b="0" i="0">
                           <a:solidFill>
-                            <a:srgbClr val="C5D2E4"/>
+                            <a:srgbClr val="CBD5E1"/>
                           </a:solidFill>
                           <a:latin typeface="Calibri"/>
                         </a:rPr>
@@ -11947,7 +11947,7 @@
                   </a:txBody>
                   <a:tcPr anchor="ctr" marL="100584" marR="100584" marT="36576" marB="36576">
                     <a:solidFill>
-                      <a:srgbClr val="121E30"/>
+                      <a:srgbClr val="2B3A50"/>
                     </a:solidFill>
                   </a:tcPr>
                 </a:tc>
@@ -11960,7 +11960,7 @@
                       <a:r>
                         <a:rPr sz="1500" b="0" i="0">
                           <a:solidFill>
-                            <a:srgbClr val="C5D2E4"/>
+                            <a:srgbClr val="CBD5E1"/>
                           </a:solidFill>
                           <a:latin typeface="Calibri"/>
                         </a:rPr>
@@ -11970,7 +11970,7 @@
                   </a:txBody>
                   <a:tcPr anchor="ctr" marL="100584" marR="100584" marT="36576" marB="36576">
                     <a:solidFill>
-                      <a:srgbClr val="121E30"/>
+                      <a:srgbClr val="2B3A50"/>
                     </a:solidFill>
                   </a:tcPr>
                 </a:tc>
@@ -12017,7 +12017,7 @@
             <a:r>
               <a:rPr sz="1750" b="0" i="0">
                 <a:solidFill>
-                  <a:srgbClr val="C5D2E4"/>
+                  <a:srgbClr val="CBD5E1"/>
                 </a:solidFill>
                 <a:latin typeface="Calibri"/>
               </a:rPr>
@@ -12041,7 +12041,7 @@
             <a:r>
               <a:rPr sz="1750" b="0" i="0">
                 <a:solidFill>
-                  <a:srgbClr val="C5D2E4"/>
+                  <a:srgbClr val="CBD5E1"/>
                 </a:solidFill>
                 <a:latin typeface="Calibri"/>
               </a:rPr>
@@ -12065,7 +12065,7 @@
             <a:r>
               <a:rPr sz="1750" b="0" i="0">
                 <a:solidFill>
-                  <a:srgbClr val="C5D2E4"/>
+                  <a:srgbClr val="CBD5E1"/>
                 </a:solidFill>
                 <a:latin typeface="Calibri"/>
               </a:rPr>
@@ -12089,7 +12089,7 @@
             <a:r>
               <a:rPr sz="1750" b="0" i="0">
                 <a:solidFill>
-                  <a:srgbClr val="C5D2E4"/>
+                  <a:srgbClr val="CBD5E1"/>
                 </a:solidFill>
                 <a:latin typeface="Calibri"/>
               </a:rPr>
@@ -12112,7 +12112,7 @@
     <p:bg>
       <p:bgPr>
         <a:solidFill>
-          <a:srgbClr val="0B1220"/>
+          <a:srgbClr val="1E293B"/>
         </a:solidFill>
         <a:effectLst/>
       </p:bgPr>
@@ -12188,7 +12188,7 @@
             <a:r>
               <a:rPr sz="2900" b="1" i="0">
                 <a:solidFill>
-                  <a:srgbClr val="F2F6FB"/>
+                  <a:srgbClr val="F8FAFC"/>
                 </a:solidFill>
                 <a:latin typeface="Calibri Light"/>
               </a:rPr>
@@ -12267,7 +12267,7 @@
             <a:r>
               <a:rPr sz="1100" b="0" i="0">
                 <a:solidFill>
-                  <a:srgbClr val="55688A"/>
+                  <a:srgbClr val="8296B0"/>
                 </a:solidFill>
                 <a:latin typeface="Calibri"/>
               </a:rPr>
@@ -12314,7 +12314,7 @@
             <a:r>
               <a:rPr sz="1700" b="1" i="0">
                 <a:solidFill>
-                  <a:srgbClr val="F2F6FB"/>
+                  <a:srgbClr val="F8FAFC"/>
                 </a:solidFill>
                 <a:latin typeface="Calibri"/>
               </a:rPr>
@@ -12323,7 +12323,7 @@
             <a:r>
               <a:rPr sz="1700" b="0" i="0">
                 <a:solidFill>
-                  <a:srgbClr val="C5D2E4"/>
+                  <a:srgbClr val="CBD5E1"/>
                 </a:solidFill>
                 <a:latin typeface="Calibri"/>
               </a:rPr>
@@ -12347,7 +12347,7 @@
             <a:r>
               <a:rPr sz="1700" b="1" i="0">
                 <a:solidFill>
-                  <a:srgbClr val="F2F6FB"/>
+                  <a:srgbClr val="F8FAFC"/>
                 </a:solidFill>
                 <a:latin typeface="Calibri"/>
               </a:rPr>
@@ -12356,7 +12356,7 @@
             <a:r>
               <a:rPr sz="1700" b="0" i="0">
                 <a:solidFill>
-                  <a:srgbClr val="C5D2E4"/>
+                  <a:srgbClr val="CBD5E1"/>
                 </a:solidFill>
                 <a:latin typeface="Calibri"/>
               </a:rPr>
@@ -12374,7 +12374,7 @@
             <a:r>
               <a:rPr sz="1700" b="0" i="0">
                 <a:solidFill>
-                  <a:srgbClr val="C5D2E4"/>
+                  <a:srgbClr val="CBD5E1"/>
                 </a:solidFill>
                 <a:latin typeface="Calibri"/>
               </a:rPr>
@@ -12392,7 +12392,7 @@
             <a:r>
               <a:rPr sz="1700" b="0" i="0">
                 <a:solidFill>
-                  <a:srgbClr val="C5D2E4"/>
+                  <a:srgbClr val="CBD5E1"/>
                 </a:solidFill>
                 <a:latin typeface="Calibri"/>
               </a:rPr>
@@ -12416,7 +12416,7 @@
             <a:r>
               <a:rPr sz="1700" b="0" i="0">
                 <a:solidFill>
-                  <a:srgbClr val="C5D2E4"/>
+                  <a:srgbClr val="CBD5E1"/>
                 </a:solidFill>
                 <a:latin typeface="Calibri"/>
               </a:rPr>
@@ -12425,7 +12425,7 @@
             <a:r>
               <a:rPr sz="1700" b="0" i="1">
                 <a:solidFill>
-                  <a:srgbClr val="C5D2E4"/>
+                  <a:srgbClr val="CBD5E1"/>
                 </a:solidFill>
                 <a:latin typeface="Calibri"/>
               </a:rPr>
@@ -12434,7 +12434,7 @@
             <a:r>
               <a:rPr sz="1700" b="0" i="0">
                 <a:solidFill>
-                  <a:srgbClr val="C5D2E4"/>
+                  <a:srgbClr val="CBD5E1"/>
                 </a:solidFill>
                 <a:latin typeface="Calibri"/>
               </a:rPr>
@@ -12458,7 +12458,7 @@
             <a:r>
               <a:rPr sz="1700" b="0" i="0">
                 <a:solidFill>
-                  <a:srgbClr val="C5D2E4"/>
+                  <a:srgbClr val="CBD5E1"/>
                 </a:solidFill>
                 <a:latin typeface="Calibri"/>
               </a:rPr>
@@ -12476,7 +12476,7 @@
             <a:r>
               <a:rPr sz="1700" b="0" i="0">
                 <a:solidFill>
-                  <a:srgbClr val="C5D2E4"/>
+                  <a:srgbClr val="CBD5E1"/>
                 </a:solidFill>
                 <a:latin typeface="Calibri"/>
               </a:rPr>
@@ -12499,7 +12499,7 @@
     <p:bg>
       <p:bgPr>
         <a:solidFill>
-          <a:srgbClr val="0B1220"/>
+          <a:srgbClr val="1E293B"/>
         </a:solidFill>
         <a:effectLst/>
       </p:bgPr>
@@ -12575,7 +12575,7 @@
             <a:r>
               <a:rPr sz="2900" b="1" i="0">
                 <a:solidFill>
-                  <a:srgbClr val="F2F6FB"/>
+                  <a:srgbClr val="F8FAFC"/>
                 </a:solidFill>
                 <a:latin typeface="Calibri Light"/>
               </a:rPr>
@@ -12654,7 +12654,7 @@
             <a:r>
               <a:rPr sz="1100" b="0" i="0">
                 <a:solidFill>
-                  <a:srgbClr val="55688A"/>
+                  <a:srgbClr val="8296B0"/>
                 </a:solidFill>
                 <a:latin typeface="Calibri"/>
               </a:rPr>
@@ -12708,7 +12708,7 @@
                   </a:txBody>
                   <a:tcPr anchor="ctr" marL="100584" marR="100584" marT="36576" marB="36576">
                     <a:solidFill>
-                      <a:srgbClr val="12303A"/>
+                      <a:srgbClr val="334155"/>
                     </a:solidFill>
                   </a:tcPr>
                 </a:tc>
@@ -12731,7 +12731,7 @@
                   </a:txBody>
                   <a:tcPr anchor="ctr" marL="100584" marR="100584" marT="36576" marB="36576">
                     <a:solidFill>
-                      <a:srgbClr val="12303A"/>
+                      <a:srgbClr val="334155"/>
                     </a:solidFill>
                   </a:tcPr>
                 </a:tc>
@@ -12754,7 +12754,7 @@
                   </a:txBody>
                   <a:tcPr anchor="ctr" marL="100584" marR="100584" marT="36576" marB="36576">
                     <a:solidFill>
-                      <a:srgbClr val="12303A"/>
+                      <a:srgbClr val="334155"/>
                     </a:solidFill>
                   </a:tcPr>
                 </a:tc>
@@ -12777,7 +12777,7 @@
                   </a:txBody>
                   <a:tcPr anchor="ctr" marL="100584" marR="100584" marT="36576" marB="36576">
                     <a:solidFill>
-                      <a:srgbClr val="12303A"/>
+                      <a:srgbClr val="334155"/>
                     </a:solidFill>
                   </a:tcPr>
                 </a:tc>
@@ -12800,7 +12800,7 @@
                   </a:txBody>
                   <a:tcPr anchor="ctr" marL="100584" marR="100584" marT="36576" marB="36576">
                     <a:solidFill>
-                      <a:srgbClr val="12303A"/>
+                      <a:srgbClr val="334155"/>
                     </a:solidFill>
                   </a:tcPr>
                 </a:tc>
@@ -12815,7 +12815,7 @@
                       <a:r>
                         <a:rPr sz="1350" b="0" i="0">
                           <a:solidFill>
-                            <a:srgbClr val="C5D2E4"/>
+                            <a:srgbClr val="CBD5E1"/>
                           </a:solidFill>
                           <a:latin typeface="Calibri"/>
                         </a:rPr>
@@ -12825,7 +12825,7 @@
                   </a:txBody>
                   <a:tcPr anchor="ctr" marL="100584" marR="100584" marT="36576" marB="36576">
                     <a:solidFill>
-                      <a:srgbClr val="0E1929"/>
+                      <a:srgbClr val="243247"/>
                     </a:solidFill>
                   </a:tcPr>
                 </a:tc>
@@ -12838,7 +12838,7 @@
                       <a:r>
                         <a:rPr sz="1350" b="0" i="0">
                           <a:solidFill>
-                            <a:srgbClr val="C5D2E4"/>
+                            <a:srgbClr val="CBD5E1"/>
                           </a:solidFill>
                           <a:latin typeface="Calibri"/>
                         </a:rPr>
@@ -12848,7 +12848,7 @@
                   </a:txBody>
                   <a:tcPr anchor="ctr" marL="100584" marR="100584" marT="36576" marB="36576">
                     <a:solidFill>
-                      <a:srgbClr val="0E1929"/>
+                      <a:srgbClr val="243247"/>
                     </a:solidFill>
                   </a:tcPr>
                 </a:tc>
@@ -12861,7 +12861,7 @@
                       <a:r>
                         <a:rPr sz="1350" b="0" i="0">
                           <a:solidFill>
-                            <a:srgbClr val="C5D2E4"/>
+                            <a:srgbClr val="CBD5E1"/>
                           </a:solidFill>
                           <a:latin typeface="Calibri"/>
                         </a:rPr>
@@ -12871,7 +12871,7 @@
                   </a:txBody>
                   <a:tcPr anchor="ctr" marL="100584" marR="100584" marT="36576" marB="36576">
                     <a:solidFill>
-                      <a:srgbClr val="0E1929"/>
+                      <a:srgbClr val="243247"/>
                     </a:solidFill>
                   </a:tcPr>
                 </a:tc>
@@ -12884,7 +12884,7 @@
                       <a:r>
                         <a:rPr sz="1350" b="0" i="0">
                           <a:solidFill>
-                            <a:srgbClr val="C5D2E4"/>
+                            <a:srgbClr val="CBD5E1"/>
                           </a:solidFill>
                           <a:latin typeface="Calibri"/>
                         </a:rPr>
@@ -12894,7 +12894,7 @@
                   </a:txBody>
                   <a:tcPr anchor="ctr" marL="100584" marR="100584" marT="36576" marB="36576">
                     <a:solidFill>
-                      <a:srgbClr val="0E1929"/>
+                      <a:srgbClr val="243247"/>
                     </a:solidFill>
                   </a:tcPr>
                 </a:tc>
@@ -12907,7 +12907,7 @@
                       <a:r>
                         <a:rPr sz="1350" b="0" i="0">
                           <a:solidFill>
-                            <a:srgbClr val="C5D2E4"/>
+                            <a:srgbClr val="CBD5E1"/>
                           </a:solidFill>
                           <a:latin typeface="Calibri"/>
                         </a:rPr>
@@ -12917,7 +12917,7 @@
                   </a:txBody>
                   <a:tcPr anchor="ctr" marL="100584" marR="100584" marT="36576" marB="36576">
                     <a:solidFill>
-                      <a:srgbClr val="0E1929"/>
+                      <a:srgbClr val="243247"/>
                     </a:solidFill>
                   </a:tcPr>
                 </a:tc>
@@ -12932,7 +12932,7 @@
                       <a:r>
                         <a:rPr sz="1350" b="0" i="0">
                           <a:solidFill>
-                            <a:srgbClr val="C5D2E4"/>
+                            <a:srgbClr val="CBD5E1"/>
                           </a:solidFill>
                           <a:latin typeface="Calibri"/>
                         </a:rPr>
@@ -12942,7 +12942,7 @@
                   </a:txBody>
                   <a:tcPr anchor="ctr" marL="100584" marR="100584" marT="36576" marB="36576">
                     <a:solidFill>
-                      <a:srgbClr val="121E30"/>
+                      <a:srgbClr val="2B3A50"/>
                     </a:solidFill>
                   </a:tcPr>
                 </a:tc>
@@ -12955,7 +12955,7 @@
                       <a:r>
                         <a:rPr sz="1350" b="0" i="0">
                           <a:solidFill>
-                            <a:srgbClr val="C5D2E4"/>
+                            <a:srgbClr val="CBD5E1"/>
                           </a:solidFill>
                           <a:latin typeface="Calibri"/>
                         </a:rPr>
@@ -12965,7 +12965,7 @@
                   </a:txBody>
                   <a:tcPr anchor="ctr" marL="100584" marR="100584" marT="36576" marB="36576">
                     <a:solidFill>
-                      <a:srgbClr val="121E30"/>
+                      <a:srgbClr val="2B3A50"/>
                     </a:solidFill>
                   </a:tcPr>
                 </a:tc>
@@ -12978,7 +12978,7 @@
                       <a:r>
                         <a:rPr sz="1350" b="0" i="0">
                           <a:solidFill>
-                            <a:srgbClr val="C5D2E4"/>
+                            <a:srgbClr val="CBD5E1"/>
                           </a:solidFill>
                           <a:latin typeface="Calibri"/>
                         </a:rPr>
@@ -12988,7 +12988,7 @@
                   </a:txBody>
                   <a:tcPr anchor="ctr" marL="100584" marR="100584" marT="36576" marB="36576">
                     <a:solidFill>
-                      <a:srgbClr val="121E30"/>
+                      <a:srgbClr val="2B3A50"/>
                     </a:solidFill>
                   </a:tcPr>
                 </a:tc>
@@ -13001,7 +13001,7 @@
                       <a:r>
                         <a:rPr sz="1350" b="0" i="0">
                           <a:solidFill>
-                            <a:srgbClr val="C5D2E4"/>
+                            <a:srgbClr val="CBD5E1"/>
                           </a:solidFill>
                           <a:latin typeface="Calibri"/>
                         </a:rPr>
@@ -13011,7 +13011,7 @@
                   </a:txBody>
                   <a:tcPr anchor="ctr" marL="100584" marR="100584" marT="36576" marB="36576">
                     <a:solidFill>
-                      <a:srgbClr val="121E30"/>
+                      <a:srgbClr val="2B3A50"/>
                     </a:solidFill>
                   </a:tcPr>
                 </a:tc>
@@ -13024,7 +13024,7 @@
                       <a:r>
                         <a:rPr sz="1350" b="0" i="0">
                           <a:solidFill>
-                            <a:srgbClr val="C5D2E4"/>
+                            <a:srgbClr val="CBD5E1"/>
                           </a:solidFill>
                           <a:latin typeface="Calibri"/>
                         </a:rPr>
@@ -13034,7 +13034,7 @@
                   </a:txBody>
                   <a:tcPr anchor="ctr" marL="100584" marR="100584" marT="36576" marB="36576">
                     <a:solidFill>
-                      <a:srgbClr val="121E30"/>
+                      <a:srgbClr val="2B3A50"/>
                     </a:solidFill>
                   </a:tcPr>
                 </a:tc>
@@ -13049,7 +13049,7 @@
                       <a:r>
                         <a:rPr sz="1350" b="0" i="0">
                           <a:solidFill>
-                            <a:srgbClr val="C5D2E4"/>
+                            <a:srgbClr val="CBD5E1"/>
                           </a:solidFill>
                           <a:latin typeface="Calibri"/>
                         </a:rPr>
@@ -13059,7 +13059,7 @@
                   </a:txBody>
                   <a:tcPr anchor="ctr" marL="100584" marR="100584" marT="36576" marB="36576">
                     <a:solidFill>
-                      <a:srgbClr val="0E1929"/>
+                      <a:srgbClr val="243247"/>
                     </a:solidFill>
                   </a:tcPr>
                 </a:tc>
@@ -13072,7 +13072,7 @@
                       <a:r>
                         <a:rPr sz="1350" b="0" i="0">
                           <a:solidFill>
-                            <a:srgbClr val="C5D2E4"/>
+                            <a:srgbClr val="CBD5E1"/>
                           </a:solidFill>
                           <a:latin typeface="Calibri"/>
                         </a:rPr>
@@ -13082,7 +13082,7 @@
                   </a:txBody>
                   <a:tcPr anchor="ctr" marL="100584" marR="100584" marT="36576" marB="36576">
                     <a:solidFill>
-                      <a:srgbClr val="0E1929"/>
+                      <a:srgbClr val="243247"/>
                     </a:solidFill>
                   </a:tcPr>
                 </a:tc>
@@ -13095,7 +13095,7 @@
                       <a:r>
                         <a:rPr sz="1350" b="0" i="0">
                           <a:solidFill>
-                            <a:srgbClr val="C5D2E4"/>
+                            <a:srgbClr val="CBD5E1"/>
                           </a:solidFill>
                           <a:latin typeface="Calibri"/>
                         </a:rPr>
@@ -13105,7 +13105,7 @@
                   </a:txBody>
                   <a:tcPr anchor="ctr" marL="100584" marR="100584" marT="36576" marB="36576">
                     <a:solidFill>
-                      <a:srgbClr val="0E1929"/>
+                      <a:srgbClr val="243247"/>
                     </a:solidFill>
                   </a:tcPr>
                 </a:tc>
@@ -13118,7 +13118,7 @@
                       <a:r>
                         <a:rPr sz="1350" b="0" i="0">
                           <a:solidFill>
-                            <a:srgbClr val="C5D2E4"/>
+                            <a:srgbClr val="CBD5E1"/>
                           </a:solidFill>
                           <a:latin typeface="Calibri"/>
                         </a:rPr>
@@ -13128,7 +13128,7 @@
                   </a:txBody>
                   <a:tcPr anchor="ctr" marL="100584" marR="100584" marT="36576" marB="36576">
                     <a:solidFill>
-                      <a:srgbClr val="0E1929"/>
+                      <a:srgbClr val="243247"/>
                     </a:solidFill>
                   </a:tcPr>
                 </a:tc>
@@ -13141,7 +13141,7 @@
                       <a:r>
                         <a:rPr sz="1350" b="0" i="0">
                           <a:solidFill>
-                            <a:srgbClr val="C5D2E4"/>
+                            <a:srgbClr val="CBD5E1"/>
                           </a:solidFill>
                           <a:latin typeface="Calibri"/>
                         </a:rPr>
@@ -13151,7 +13151,7 @@
                   </a:txBody>
                   <a:tcPr anchor="ctr" marL="100584" marR="100584" marT="36576" marB="36576">
                     <a:solidFill>
-                      <a:srgbClr val="0E1929"/>
+                      <a:srgbClr val="243247"/>
                     </a:solidFill>
                   </a:tcPr>
                 </a:tc>
@@ -13166,7 +13166,7 @@
                       <a:r>
                         <a:rPr sz="1350" b="0" i="0">
                           <a:solidFill>
-                            <a:srgbClr val="C5D2E4"/>
+                            <a:srgbClr val="CBD5E1"/>
                           </a:solidFill>
                           <a:latin typeface="Calibri"/>
                         </a:rPr>
@@ -13176,7 +13176,7 @@
                   </a:txBody>
                   <a:tcPr anchor="ctr" marL="100584" marR="100584" marT="36576" marB="36576">
                     <a:solidFill>
-                      <a:srgbClr val="121E30"/>
+                      <a:srgbClr val="2B3A50"/>
                     </a:solidFill>
                   </a:tcPr>
                 </a:tc>
@@ -13189,7 +13189,7 @@
                       <a:r>
                         <a:rPr sz="1350" b="0" i="0">
                           <a:solidFill>
-                            <a:srgbClr val="C5D2E4"/>
+                            <a:srgbClr val="CBD5E1"/>
                           </a:solidFill>
                           <a:latin typeface="Calibri"/>
                         </a:rPr>
@@ -13199,7 +13199,7 @@
                   </a:txBody>
                   <a:tcPr anchor="ctr" marL="100584" marR="100584" marT="36576" marB="36576">
                     <a:solidFill>
-                      <a:srgbClr val="121E30"/>
+                      <a:srgbClr val="2B3A50"/>
                     </a:solidFill>
                   </a:tcPr>
                 </a:tc>
@@ -13212,7 +13212,7 @@
                       <a:r>
                         <a:rPr sz="1350" b="0" i="0">
                           <a:solidFill>
-                            <a:srgbClr val="C5D2E4"/>
+                            <a:srgbClr val="CBD5E1"/>
                           </a:solidFill>
                           <a:latin typeface="Calibri"/>
                         </a:rPr>
@@ -13222,7 +13222,7 @@
                   </a:txBody>
                   <a:tcPr anchor="ctr" marL="100584" marR="100584" marT="36576" marB="36576">
                     <a:solidFill>
-                      <a:srgbClr val="121E30"/>
+                      <a:srgbClr val="2B3A50"/>
                     </a:solidFill>
                   </a:tcPr>
                 </a:tc>
@@ -13235,7 +13235,7 @@
                       <a:r>
                         <a:rPr sz="1350" b="0" i="0">
                           <a:solidFill>
-                            <a:srgbClr val="C5D2E4"/>
+                            <a:srgbClr val="CBD5E1"/>
                           </a:solidFill>
                           <a:latin typeface="Calibri"/>
                         </a:rPr>
@@ -13245,7 +13245,7 @@
                   </a:txBody>
                   <a:tcPr anchor="ctr" marL="100584" marR="100584" marT="36576" marB="36576">
                     <a:solidFill>
-                      <a:srgbClr val="121E30"/>
+                      <a:srgbClr val="2B3A50"/>
                     </a:solidFill>
                   </a:tcPr>
                 </a:tc>
@@ -13258,7 +13258,7 @@
                       <a:r>
                         <a:rPr sz="1350" b="0" i="0">
                           <a:solidFill>
-                            <a:srgbClr val="C5D2E4"/>
+                            <a:srgbClr val="CBD5E1"/>
                           </a:solidFill>
                           <a:latin typeface="Calibri"/>
                         </a:rPr>
@@ -13268,7 +13268,7 @@
                   </a:txBody>
                   <a:tcPr anchor="ctr" marL="100584" marR="100584" marT="36576" marB="36576">
                     <a:solidFill>
-                      <a:srgbClr val="121E30"/>
+                      <a:srgbClr val="2B3A50"/>
                     </a:solidFill>
                   </a:tcPr>
                 </a:tc>
@@ -13315,7 +13315,7 @@
             <a:r>
               <a:rPr sz="1600" b="0" i="0">
                 <a:solidFill>
-                  <a:srgbClr val="C5D2E4"/>
+                  <a:srgbClr val="CBD5E1"/>
                 </a:solidFill>
                 <a:latin typeface="Calibri"/>
               </a:rPr>
@@ -13339,7 +13339,7 @@
             <a:r>
               <a:rPr sz="1600" b="0" i="0">
                 <a:solidFill>
-                  <a:srgbClr val="C5D2E4"/>
+                  <a:srgbClr val="CBD5E1"/>
                 </a:solidFill>
                 <a:latin typeface="Calibri"/>
               </a:rPr>
@@ -13363,7 +13363,7 @@
             <a:r>
               <a:rPr sz="1600" b="0" i="0">
                 <a:solidFill>
-                  <a:srgbClr val="C5D2E4"/>
+                  <a:srgbClr val="CBD5E1"/>
                 </a:solidFill>
                 <a:latin typeface="Calibri"/>
               </a:rPr>
@@ -13386,7 +13386,7 @@
     <p:bg>
       <p:bgPr>
         <a:solidFill>
-          <a:srgbClr val="0B1220"/>
+          <a:srgbClr val="1E293B"/>
         </a:solidFill>
         <a:effectLst/>
       </p:bgPr>
@@ -13462,7 +13462,7 @@
             <a:r>
               <a:rPr sz="2900" b="1" i="0">
                 <a:solidFill>
-                  <a:srgbClr val="F2F6FB"/>
+                  <a:srgbClr val="F8FAFC"/>
                 </a:solidFill>
                 <a:latin typeface="Calibri Light"/>
               </a:rPr>
@@ -13541,7 +13541,7 @@
             <a:r>
               <a:rPr sz="1100" b="0" i="0">
                 <a:solidFill>
-                  <a:srgbClr val="55688A"/>
+                  <a:srgbClr val="8296B0"/>
                 </a:solidFill>
                 <a:latin typeface="Calibri"/>
               </a:rPr>
@@ -13588,7 +13588,7 @@
             <a:r>
               <a:rPr sz="1700" b="1" i="0">
                 <a:solidFill>
-                  <a:srgbClr val="F2F6FB"/>
+                  <a:srgbClr val="F8FAFC"/>
                 </a:solidFill>
                 <a:latin typeface="Calibri"/>
               </a:rPr>
@@ -13597,7 +13597,7 @@
             <a:r>
               <a:rPr sz="1700" b="0" i="0">
                 <a:solidFill>
-                  <a:srgbClr val="C5D2E4"/>
+                  <a:srgbClr val="CBD5E1"/>
                 </a:solidFill>
                 <a:latin typeface="Calibri"/>
               </a:rPr>
@@ -13621,7 +13621,7 @@
             <a:r>
               <a:rPr sz="1700" b="0" i="0">
                 <a:solidFill>
-                  <a:srgbClr val="C5D2E4"/>
+                  <a:srgbClr val="CBD5E1"/>
                 </a:solidFill>
                 <a:latin typeface="Calibri"/>
               </a:rPr>
@@ -13639,7 +13639,7 @@
             <a:r>
               <a:rPr sz="1700" b="0" i="0">
                 <a:solidFill>
-                  <a:srgbClr val="C5D2E4"/>
+                  <a:srgbClr val="CBD5E1"/>
                 </a:solidFill>
                 <a:latin typeface="Calibri"/>
               </a:rPr>
@@ -13657,7 +13657,7 @@
             <a:r>
               <a:rPr sz="1700" b="0" i="0">
                 <a:solidFill>
-                  <a:srgbClr val="C5D2E4"/>
+                  <a:srgbClr val="CBD5E1"/>
                 </a:solidFill>
                 <a:latin typeface="Calibri"/>
               </a:rPr>
@@ -13666,7 +13666,7 @@
             <a:r>
               <a:rPr sz="1700" b="0" i="1">
                 <a:solidFill>
-                  <a:srgbClr val="93A6C0"/>
+                  <a:srgbClr val="94A3B8"/>
                 </a:solidFill>
                 <a:latin typeface="Calibri"/>
               </a:rPr>
@@ -13675,7 +13675,7 @@
             <a:r>
               <a:rPr sz="1700" b="0" i="0">
                 <a:solidFill>
-                  <a:srgbClr val="C5D2E4"/>
+                  <a:srgbClr val="CBD5E1"/>
                 </a:solidFill>
                 <a:latin typeface="Calibri"/>
               </a:rPr>
@@ -13684,7 +13684,7 @@
             <a:r>
               <a:rPr sz="1700" b="0" i="1">
                 <a:solidFill>
-                  <a:srgbClr val="93A6C0"/>
+                  <a:srgbClr val="94A3B8"/>
                 </a:solidFill>
                 <a:latin typeface="Calibri"/>
               </a:rPr>
@@ -13693,7 +13693,7 @@
             <a:r>
               <a:rPr sz="1700" b="0" i="0">
                 <a:solidFill>
-                  <a:srgbClr val="C5D2E4"/>
+                  <a:srgbClr val="CBD5E1"/>
                 </a:solidFill>
                 <a:latin typeface="Calibri"/>
               </a:rPr>
@@ -13717,7 +13717,7 @@
             <a:r>
               <a:rPr sz="1700" b="1" i="0">
                 <a:solidFill>
-                  <a:srgbClr val="F2F6FB"/>
+                  <a:srgbClr val="F8FAFC"/>
                 </a:solidFill>
                 <a:latin typeface="Calibri"/>
               </a:rPr>
@@ -13726,7 +13726,7 @@
             <a:r>
               <a:rPr sz="1700" b="0" i="0">
                 <a:solidFill>
-                  <a:srgbClr val="C5D2E4"/>
+                  <a:srgbClr val="CBD5E1"/>
                 </a:solidFill>
                 <a:latin typeface="Calibri"/>
               </a:rPr>
@@ -13750,7 +13750,7 @@
             <a:r>
               <a:rPr sz="1700" b="0" i="0">
                 <a:solidFill>
-                  <a:srgbClr val="C5D2E4"/>
+                  <a:srgbClr val="CBD5E1"/>
                 </a:solidFill>
                 <a:latin typeface="Calibri"/>
               </a:rPr>
@@ -13773,7 +13773,7 @@
     <p:bg>
       <p:bgPr>
         <a:solidFill>
-          <a:srgbClr val="0B1220"/>
+          <a:srgbClr val="1E293B"/>
         </a:solidFill>
         <a:effectLst/>
       </p:bgPr>
@@ -13835,7 +13835,7 @@
             <a:r>
               <a:rPr sz="1100" b="0" i="0">
                 <a:solidFill>
-                  <a:srgbClr val="55688A"/>
+                  <a:srgbClr val="8296B0"/>
                 </a:solidFill>
                 <a:latin typeface="Calibri"/>
               </a:rPr>
@@ -13858,7 +13858,7 @@
     <p:bg>
       <p:bgPr>
         <a:solidFill>
-          <a:srgbClr val="0B1220"/>
+          <a:srgbClr val="1E293B"/>
         </a:solidFill>
         <a:effectLst/>
       </p:bgPr>
@@ -13934,7 +13934,7 @@
             <a:r>
               <a:rPr sz="2900" b="1" i="0">
                 <a:solidFill>
-                  <a:srgbClr val="F2F6FB"/>
+                  <a:srgbClr val="F8FAFC"/>
                 </a:solidFill>
                 <a:latin typeface="Calibri Light"/>
               </a:rPr>
@@ -14013,7 +14013,7 @@
             <a:r>
               <a:rPr sz="1100" b="0" i="0">
                 <a:solidFill>
-                  <a:srgbClr val="55688A"/>
+                  <a:srgbClr val="8296B0"/>
                 </a:solidFill>
                 <a:latin typeface="Calibri"/>
               </a:rPr>
@@ -14065,7 +14065,7 @@
                   </a:txBody>
                   <a:tcPr anchor="ctr" marL="100584" marR="100584" marT="36576" marB="36576">
                     <a:solidFill>
-                      <a:srgbClr val="12303A"/>
+                      <a:srgbClr val="334155"/>
                     </a:solidFill>
                   </a:tcPr>
                 </a:tc>
@@ -14088,7 +14088,7 @@
                   </a:txBody>
                   <a:tcPr anchor="ctr" marL="100584" marR="100584" marT="36576" marB="36576">
                     <a:solidFill>
-                      <a:srgbClr val="12303A"/>
+                      <a:srgbClr val="334155"/>
                     </a:solidFill>
                   </a:tcPr>
                 </a:tc>
@@ -14111,7 +14111,7 @@
                   </a:txBody>
                   <a:tcPr anchor="ctr" marL="100584" marR="100584" marT="36576" marB="36576">
                     <a:solidFill>
-                      <a:srgbClr val="12303A"/>
+                      <a:srgbClr val="334155"/>
                     </a:solidFill>
                   </a:tcPr>
                 </a:tc>
@@ -14126,7 +14126,7 @@
                       <a:r>
                         <a:rPr sz="1350" b="0" i="0">
                           <a:solidFill>
-                            <a:srgbClr val="C5D2E4"/>
+                            <a:srgbClr val="CBD5E1"/>
                           </a:solidFill>
                           <a:latin typeface="Calibri"/>
                         </a:rPr>
@@ -14136,7 +14136,7 @@
                   </a:txBody>
                   <a:tcPr anchor="ctr" marL="100584" marR="100584" marT="36576" marB="36576">
                     <a:solidFill>
-                      <a:srgbClr val="0E1929"/>
+                      <a:srgbClr val="243247"/>
                     </a:solidFill>
                   </a:tcPr>
                 </a:tc>
@@ -14149,7 +14149,7 @@
                       <a:r>
                         <a:rPr sz="1350" b="0" i="0">
                           <a:solidFill>
-                            <a:srgbClr val="C5D2E4"/>
+                            <a:srgbClr val="CBD5E1"/>
                           </a:solidFill>
                           <a:latin typeface="Calibri"/>
                         </a:rPr>
@@ -14159,7 +14159,7 @@
                   </a:txBody>
                   <a:tcPr anchor="ctr" marL="100584" marR="100584" marT="36576" marB="36576">
                     <a:solidFill>
-                      <a:srgbClr val="0E1929"/>
+                      <a:srgbClr val="243247"/>
                     </a:solidFill>
                   </a:tcPr>
                 </a:tc>
@@ -14172,7 +14172,7 @@
                       <a:r>
                         <a:rPr sz="1350" b="0" i="0">
                           <a:solidFill>
-                            <a:srgbClr val="C5D2E4"/>
+                            <a:srgbClr val="CBD5E1"/>
                           </a:solidFill>
                           <a:latin typeface="Calibri"/>
                         </a:rPr>
@@ -14182,7 +14182,7 @@
                   </a:txBody>
                   <a:tcPr anchor="ctr" marL="100584" marR="100584" marT="36576" marB="36576">
                     <a:solidFill>
-                      <a:srgbClr val="0E1929"/>
+                      <a:srgbClr val="243247"/>
                     </a:solidFill>
                   </a:tcPr>
                 </a:tc>
@@ -14197,7 +14197,7 @@
                       <a:r>
                         <a:rPr sz="1350" b="0" i="0">
                           <a:solidFill>
-                            <a:srgbClr val="C5D2E4"/>
+                            <a:srgbClr val="CBD5E1"/>
                           </a:solidFill>
                           <a:latin typeface="Calibri"/>
                         </a:rPr>
@@ -14207,7 +14207,7 @@
                   </a:txBody>
                   <a:tcPr anchor="ctr" marL="100584" marR="100584" marT="36576" marB="36576">
                     <a:solidFill>
-                      <a:srgbClr val="121E30"/>
+                      <a:srgbClr val="2B3A50"/>
                     </a:solidFill>
                   </a:tcPr>
                 </a:tc>
@@ -14220,7 +14220,7 @@
                       <a:r>
                         <a:rPr sz="1350" b="0" i="0">
                           <a:solidFill>
-                            <a:srgbClr val="C5D2E4"/>
+                            <a:srgbClr val="CBD5E1"/>
                           </a:solidFill>
                           <a:latin typeface="Calibri"/>
                         </a:rPr>
@@ -14230,7 +14230,7 @@
                   </a:txBody>
                   <a:tcPr anchor="ctr" marL="100584" marR="100584" marT="36576" marB="36576">
                     <a:solidFill>
-                      <a:srgbClr val="121E30"/>
+                      <a:srgbClr val="2B3A50"/>
                     </a:solidFill>
                   </a:tcPr>
                 </a:tc>
@@ -14243,7 +14243,7 @@
                       <a:r>
                         <a:rPr sz="1350" b="0" i="0">
                           <a:solidFill>
-                            <a:srgbClr val="C5D2E4"/>
+                            <a:srgbClr val="CBD5E1"/>
                           </a:solidFill>
                           <a:latin typeface="Calibri"/>
                         </a:rPr>
@@ -14253,7 +14253,7 @@
                   </a:txBody>
                   <a:tcPr anchor="ctr" marL="100584" marR="100584" marT="36576" marB="36576">
                     <a:solidFill>
-                      <a:srgbClr val="121E30"/>
+                      <a:srgbClr val="2B3A50"/>
                     </a:solidFill>
                   </a:tcPr>
                 </a:tc>
@@ -14268,7 +14268,7 @@
                       <a:r>
                         <a:rPr sz="1350" b="0" i="0">
                           <a:solidFill>
-                            <a:srgbClr val="C5D2E4"/>
+                            <a:srgbClr val="CBD5E1"/>
                           </a:solidFill>
                           <a:latin typeface="Calibri"/>
                         </a:rPr>
@@ -14278,7 +14278,7 @@
                   </a:txBody>
                   <a:tcPr anchor="ctr" marL="100584" marR="100584" marT="36576" marB="36576">
                     <a:solidFill>
-                      <a:srgbClr val="0E1929"/>
+                      <a:srgbClr val="243247"/>
                     </a:solidFill>
                   </a:tcPr>
                 </a:tc>
@@ -14291,7 +14291,7 @@
                       <a:r>
                         <a:rPr sz="1350" b="0" i="0">
                           <a:solidFill>
-                            <a:srgbClr val="C5D2E4"/>
+                            <a:srgbClr val="CBD5E1"/>
                           </a:solidFill>
                           <a:latin typeface="Calibri"/>
                         </a:rPr>
@@ -14301,7 +14301,7 @@
                   </a:txBody>
                   <a:tcPr anchor="ctr" marL="100584" marR="100584" marT="36576" marB="36576">
                     <a:solidFill>
-                      <a:srgbClr val="0E1929"/>
+                      <a:srgbClr val="243247"/>
                     </a:solidFill>
                   </a:tcPr>
                 </a:tc>
@@ -14314,7 +14314,7 @@
                       <a:r>
                         <a:rPr sz="1350" b="0" i="0">
                           <a:solidFill>
-                            <a:srgbClr val="C5D2E4"/>
+                            <a:srgbClr val="CBD5E1"/>
                           </a:solidFill>
                           <a:latin typeface="Calibri"/>
                         </a:rPr>
@@ -14324,7 +14324,7 @@
                   </a:txBody>
                   <a:tcPr anchor="ctr" marL="100584" marR="100584" marT="36576" marB="36576">
                     <a:solidFill>
-                      <a:srgbClr val="0E1929"/>
+                      <a:srgbClr val="243247"/>
                     </a:solidFill>
                   </a:tcPr>
                 </a:tc>
@@ -14339,7 +14339,7 @@
                       <a:r>
                         <a:rPr sz="1350" b="0" i="0">
                           <a:solidFill>
-                            <a:srgbClr val="C5D2E4"/>
+                            <a:srgbClr val="CBD5E1"/>
                           </a:solidFill>
                           <a:latin typeface="Calibri"/>
                         </a:rPr>
@@ -14349,7 +14349,7 @@
                   </a:txBody>
                   <a:tcPr anchor="ctr" marL="100584" marR="100584" marT="36576" marB="36576">
                     <a:solidFill>
-                      <a:srgbClr val="121E30"/>
+                      <a:srgbClr val="2B3A50"/>
                     </a:solidFill>
                   </a:tcPr>
                 </a:tc>
@@ -14362,7 +14362,7 @@
                       <a:r>
                         <a:rPr sz="1350" b="0" i="0">
                           <a:solidFill>
-                            <a:srgbClr val="C5D2E4"/>
+                            <a:srgbClr val="CBD5E1"/>
                           </a:solidFill>
                           <a:latin typeface="Calibri"/>
                         </a:rPr>
@@ -14372,7 +14372,7 @@
                   </a:txBody>
                   <a:tcPr anchor="ctr" marL="100584" marR="100584" marT="36576" marB="36576">
                     <a:solidFill>
-                      <a:srgbClr val="121E30"/>
+                      <a:srgbClr val="2B3A50"/>
                     </a:solidFill>
                   </a:tcPr>
                 </a:tc>
@@ -14385,7 +14385,7 @@
                       <a:r>
                         <a:rPr sz="1350" b="0" i="0">
                           <a:solidFill>
-                            <a:srgbClr val="C5D2E4"/>
+                            <a:srgbClr val="CBD5E1"/>
                           </a:solidFill>
                           <a:latin typeface="Calibri"/>
                         </a:rPr>
@@ -14395,7 +14395,7 @@
                   </a:txBody>
                   <a:tcPr anchor="ctr" marL="100584" marR="100584" marT="36576" marB="36576">
                     <a:solidFill>
-                      <a:srgbClr val="121E30"/>
+                      <a:srgbClr val="2B3A50"/>
                     </a:solidFill>
                   </a:tcPr>
                 </a:tc>
@@ -14410,7 +14410,7 @@
                       <a:r>
                         <a:rPr sz="1350" b="1" i="0">
                           <a:solidFill>
-                            <a:srgbClr val="F2F6FB"/>
+                            <a:srgbClr val="F8FAFC"/>
                           </a:solidFill>
                           <a:latin typeface="Calibri"/>
                         </a:rPr>
@@ -14420,7 +14420,7 @@
                   </a:txBody>
                   <a:tcPr anchor="ctr" marL="100584" marR="100584" marT="36576" marB="36576">
                     <a:solidFill>
-                      <a:srgbClr val="12303A"/>
+                      <a:srgbClr val="334155"/>
                     </a:solidFill>
                   </a:tcPr>
                 </a:tc>
@@ -14433,7 +14433,7 @@
                       <a:r>
                         <a:rPr sz="1350" b="1" i="0">
                           <a:solidFill>
-                            <a:srgbClr val="F2F6FB"/>
+                            <a:srgbClr val="F8FAFC"/>
                           </a:solidFill>
                           <a:latin typeface="Calibri"/>
                         </a:rPr>
@@ -14443,7 +14443,7 @@
                   </a:txBody>
                   <a:tcPr anchor="ctr" marL="100584" marR="100584" marT="36576" marB="36576">
                     <a:solidFill>
-                      <a:srgbClr val="12303A"/>
+                      <a:srgbClr val="334155"/>
                     </a:solidFill>
                   </a:tcPr>
                 </a:tc>
@@ -14456,7 +14456,7 @@
                       <a:r>
                         <a:rPr sz="1350" b="1" i="0">
                           <a:solidFill>
-                            <a:srgbClr val="F2F6FB"/>
+                            <a:srgbClr val="F8FAFC"/>
                           </a:solidFill>
                           <a:latin typeface="Calibri"/>
                         </a:rPr>
@@ -14466,7 +14466,7 @@
                   </a:txBody>
                   <a:tcPr anchor="ctr" marL="100584" marR="100584" marT="36576" marB="36576">
                     <a:solidFill>
-                      <a:srgbClr val="12303A"/>
+                      <a:srgbClr val="334155"/>
                     </a:solidFill>
                   </a:tcPr>
                 </a:tc>
@@ -14513,7 +14513,7 @@
             <a:r>
               <a:rPr sz="1600" b="0" i="0">
                 <a:solidFill>
-                  <a:srgbClr val="C5D2E4"/>
+                  <a:srgbClr val="CBD5E1"/>
                 </a:solidFill>
                 <a:latin typeface="Calibri"/>
               </a:rPr>
@@ -14537,7 +14537,7 @@
             <a:r>
               <a:rPr sz="1600" b="0" i="0">
                 <a:solidFill>
-                  <a:srgbClr val="C5D2E4"/>
+                  <a:srgbClr val="CBD5E1"/>
                 </a:solidFill>
                 <a:latin typeface="Calibri"/>
               </a:rPr>
@@ -14561,7 +14561,7 @@
             <a:r>
               <a:rPr sz="1600" b="0" i="0">
                 <a:solidFill>
-                  <a:srgbClr val="C5D2E4"/>
+                  <a:srgbClr val="CBD5E1"/>
                 </a:solidFill>
                 <a:latin typeface="Calibri"/>
               </a:rPr>

</xml_diff>